<commit_message>
Final README update with Kafka Databricks and CI/CD
</commit_message>
<xml_diff>
--- a/PGDDE_Capstone_Healthcare_Analytics_Pipeline_IITJ.pptx
+++ b/PGDDE_Capstone_Healthcare_Analytics_Pipeline_IITJ.pptx
@@ -4,18 +4,24 @@
   <p:sldMasterIdLst>
     <p:sldMasterId id="2147483648" r:id="rId1"/>
   </p:sldMasterIdLst>
+  <p:notesMasterIdLst>
+    <p:notesMasterId r:id="rId16"/>
+  </p:notesMasterIdLst>
   <p:sldIdLst>
     <p:sldId id="256" r:id="rId2"/>
     <p:sldId id="257" r:id="rId3"/>
     <p:sldId id="258" r:id="rId4"/>
     <p:sldId id="259" r:id="rId5"/>
     <p:sldId id="260" r:id="rId6"/>
-    <p:sldId id="261" r:id="rId7"/>
-    <p:sldId id="262" r:id="rId8"/>
-    <p:sldId id="263" r:id="rId9"/>
-    <p:sldId id="264" r:id="rId10"/>
-    <p:sldId id="265" r:id="rId11"/>
-    <p:sldId id="266" r:id="rId12"/>
+    <p:sldId id="267" r:id="rId7"/>
+    <p:sldId id="261" r:id="rId8"/>
+    <p:sldId id="268" r:id="rId9"/>
+    <p:sldId id="262" r:id="rId10"/>
+    <p:sldId id="263" r:id="rId11"/>
+    <p:sldId id="264" r:id="rId12"/>
+    <p:sldId id="269" r:id="rId13"/>
+    <p:sldId id="265" r:id="rId14"/>
+    <p:sldId id="266" r:id="rId15"/>
   </p:sldIdLst>
   <p:sldSz cx="12192000" cy="6858000"/>
   <p:notesSz cx="6858000" cy="9144000"/>
@@ -122,6 +128,440 @@
 </p:presentation>
 </file>
 
+<file path=ppt/notesMasters/notesMaster1.xml><?xml version="1.0" encoding="utf-8"?>
+<p:notesMaster xmlns:a="http://schemas.openxmlformats.org/drawingml/2006/main" xmlns:r="http://schemas.openxmlformats.org/officeDocument/2006/relationships" xmlns:p="http://schemas.openxmlformats.org/presentationml/2006/main">
+  <p:cSld>
+    <p:bg>
+      <p:bgRef idx="1001">
+        <a:schemeClr val="bg1"/>
+      </p:bgRef>
+    </p:bg>
+    <p:spTree>
+      <p:nvGrpSpPr>
+        <p:cNvPr id="1" name=""/>
+        <p:cNvGrpSpPr/>
+        <p:nvPr/>
+      </p:nvGrpSpPr>
+      <p:grpSpPr>
+        <a:xfrm>
+          <a:off x="0" y="0"/>
+          <a:ext cx="0" cy="0"/>
+          <a:chOff x="0" y="0"/>
+          <a:chExt cx="0" cy="0"/>
+        </a:xfrm>
+      </p:grpSpPr>
+      <p:sp>
+        <p:nvSpPr>
+          <p:cNvPr id="2" name="Header Placeholder 1"/>
+          <p:cNvSpPr>
+            <a:spLocks noGrp="1"/>
+          </p:cNvSpPr>
+          <p:nvPr>
+            <p:ph type="hdr" sz="quarter"/>
+          </p:nvPr>
+        </p:nvSpPr>
+        <p:spPr>
+          <a:xfrm>
+            <a:off x="0" y="0"/>
+            <a:ext cx="2971800" cy="458788"/>
+          </a:xfrm>
+          <a:prstGeom prst="rect">
+            <a:avLst/>
+          </a:prstGeom>
+        </p:spPr>
+        <p:txBody>
+          <a:bodyPr vert="horz" lIns="91440" tIns="45720" rIns="91440" bIns="45720" rtlCol="0"/>
+          <a:lstStyle>
+            <a:lvl1pPr algn="l">
+              <a:defRPr sz="1200"/>
+            </a:lvl1pPr>
+          </a:lstStyle>
+          <a:p>
+            <a:endParaRPr lang="en-GB"/>
+          </a:p>
+        </p:txBody>
+      </p:sp>
+      <p:sp>
+        <p:nvSpPr>
+          <p:cNvPr id="3" name="Date Placeholder 2"/>
+          <p:cNvSpPr>
+            <a:spLocks noGrp="1"/>
+          </p:cNvSpPr>
+          <p:nvPr>
+            <p:ph type="dt" idx="1"/>
+          </p:nvPr>
+        </p:nvSpPr>
+        <p:spPr>
+          <a:xfrm>
+            <a:off x="3884613" y="0"/>
+            <a:ext cx="2971800" cy="458788"/>
+          </a:xfrm>
+          <a:prstGeom prst="rect">
+            <a:avLst/>
+          </a:prstGeom>
+        </p:spPr>
+        <p:txBody>
+          <a:bodyPr vert="horz" lIns="91440" tIns="45720" rIns="91440" bIns="45720" rtlCol="0"/>
+          <a:lstStyle>
+            <a:lvl1pPr algn="r">
+              <a:defRPr sz="1200"/>
+            </a:lvl1pPr>
+          </a:lstStyle>
+          <a:p>
+            <a:fld id="{6CAD6177-CAEF-4E70-8DEE-78C553712586}" type="datetimeFigureOut">
+              <a:rPr lang="en-GB" smtClean="0"/>
+              <a:t>31/05/2026</a:t>
+            </a:fld>
+            <a:endParaRPr lang="en-GB"/>
+          </a:p>
+        </p:txBody>
+      </p:sp>
+      <p:sp>
+        <p:nvSpPr>
+          <p:cNvPr id="4" name="Slide Image Placeholder 3"/>
+          <p:cNvSpPr>
+            <a:spLocks noGrp="1" noRot="1" noChangeAspect="1"/>
+          </p:cNvSpPr>
+          <p:nvPr>
+            <p:ph type="sldImg" idx="2"/>
+          </p:nvPr>
+        </p:nvSpPr>
+        <p:spPr>
+          <a:xfrm>
+            <a:off x="685800" y="1143000"/>
+            <a:ext cx="5486400" cy="3086100"/>
+          </a:xfrm>
+          <a:prstGeom prst="rect">
+            <a:avLst/>
+          </a:prstGeom>
+          <a:noFill/>
+          <a:ln w="12700">
+            <a:solidFill>
+              <a:prstClr val="black"/>
+            </a:solidFill>
+          </a:ln>
+        </p:spPr>
+        <p:txBody>
+          <a:bodyPr vert="horz" lIns="91440" tIns="45720" rIns="91440" bIns="45720" rtlCol="0" anchor="ctr"/>
+          <a:lstStyle/>
+          <a:p>
+            <a:endParaRPr lang="en-GB"/>
+          </a:p>
+        </p:txBody>
+      </p:sp>
+      <p:sp>
+        <p:nvSpPr>
+          <p:cNvPr id="5" name="Notes Placeholder 4"/>
+          <p:cNvSpPr>
+            <a:spLocks noGrp="1"/>
+          </p:cNvSpPr>
+          <p:nvPr>
+            <p:ph type="body" sz="quarter" idx="3"/>
+          </p:nvPr>
+        </p:nvSpPr>
+        <p:spPr>
+          <a:xfrm>
+            <a:off x="685800" y="4400550"/>
+            <a:ext cx="5486400" cy="3600450"/>
+          </a:xfrm>
+          <a:prstGeom prst="rect">
+            <a:avLst/>
+          </a:prstGeom>
+        </p:spPr>
+        <p:txBody>
+          <a:bodyPr vert="horz" lIns="91440" tIns="45720" rIns="91440" bIns="45720" rtlCol="0"/>
+          <a:lstStyle/>
+          <a:p>
+            <a:pPr lvl="0"/>
+            <a:r>
+              <a:rPr lang="en-US"/>
+              <a:t>Click to edit Master text styles</a:t>
+            </a:r>
+          </a:p>
+          <a:p>
+            <a:pPr lvl="1"/>
+            <a:r>
+              <a:rPr lang="en-US"/>
+              <a:t>Second level</a:t>
+            </a:r>
+          </a:p>
+          <a:p>
+            <a:pPr lvl="2"/>
+            <a:r>
+              <a:rPr lang="en-US"/>
+              <a:t>Third level</a:t>
+            </a:r>
+          </a:p>
+          <a:p>
+            <a:pPr lvl="3"/>
+            <a:r>
+              <a:rPr lang="en-US"/>
+              <a:t>Fourth level</a:t>
+            </a:r>
+          </a:p>
+          <a:p>
+            <a:pPr lvl="4"/>
+            <a:r>
+              <a:rPr lang="en-US"/>
+              <a:t>Fifth level</a:t>
+            </a:r>
+            <a:endParaRPr lang="en-GB"/>
+          </a:p>
+        </p:txBody>
+      </p:sp>
+      <p:sp>
+        <p:nvSpPr>
+          <p:cNvPr id="6" name="Footer Placeholder 5"/>
+          <p:cNvSpPr>
+            <a:spLocks noGrp="1"/>
+          </p:cNvSpPr>
+          <p:nvPr>
+            <p:ph type="ftr" sz="quarter" idx="4"/>
+          </p:nvPr>
+        </p:nvSpPr>
+        <p:spPr>
+          <a:xfrm>
+            <a:off x="0" y="8685213"/>
+            <a:ext cx="2971800" cy="458787"/>
+          </a:xfrm>
+          <a:prstGeom prst="rect">
+            <a:avLst/>
+          </a:prstGeom>
+        </p:spPr>
+        <p:txBody>
+          <a:bodyPr vert="horz" lIns="91440" tIns="45720" rIns="91440" bIns="45720" rtlCol="0" anchor="b"/>
+          <a:lstStyle>
+            <a:lvl1pPr algn="l">
+              <a:defRPr sz="1200"/>
+            </a:lvl1pPr>
+          </a:lstStyle>
+          <a:p>
+            <a:endParaRPr lang="en-GB"/>
+          </a:p>
+        </p:txBody>
+      </p:sp>
+      <p:sp>
+        <p:nvSpPr>
+          <p:cNvPr id="7" name="Slide Number Placeholder 6"/>
+          <p:cNvSpPr>
+            <a:spLocks noGrp="1"/>
+          </p:cNvSpPr>
+          <p:nvPr>
+            <p:ph type="sldNum" sz="quarter" idx="5"/>
+          </p:nvPr>
+        </p:nvSpPr>
+        <p:spPr>
+          <a:xfrm>
+            <a:off x="3884613" y="8685213"/>
+            <a:ext cx="2971800" cy="458787"/>
+          </a:xfrm>
+          <a:prstGeom prst="rect">
+            <a:avLst/>
+          </a:prstGeom>
+        </p:spPr>
+        <p:txBody>
+          <a:bodyPr vert="horz" lIns="91440" tIns="45720" rIns="91440" bIns="45720" rtlCol="0" anchor="b"/>
+          <a:lstStyle>
+            <a:lvl1pPr algn="r">
+              <a:defRPr sz="1200"/>
+            </a:lvl1pPr>
+          </a:lstStyle>
+          <a:p>
+            <a:fld id="{1CC3EDED-0833-4F63-A997-9302F708B90C}" type="slidenum">
+              <a:rPr lang="en-GB" smtClean="0"/>
+              <a:t>‹#›</a:t>
+            </a:fld>
+            <a:endParaRPr lang="en-GB"/>
+          </a:p>
+        </p:txBody>
+      </p:sp>
+    </p:spTree>
+    <p:extLst>
+      <p:ext uri="{BB962C8B-B14F-4D97-AF65-F5344CB8AC3E}">
+        <p14:creationId xmlns:p14="http://schemas.microsoft.com/office/powerpoint/2010/main" val="588181457"/>
+      </p:ext>
+    </p:extLst>
+  </p:cSld>
+  <p:clrMap bg1="lt1" tx1="dk1" bg2="lt2" tx2="dk2" accent1="accent1" accent2="accent2" accent3="accent3" accent4="accent4" accent5="accent5" accent6="accent6" hlink="hlink" folHlink="folHlink"/>
+  <p:notesStyle>
+    <a:lvl1pPr marL="0" algn="l" defTabSz="914400" rtl="0" eaLnBrk="1" latinLnBrk="0" hangingPunct="1">
+      <a:defRPr sz="1200" kern="1200">
+        <a:solidFill>
+          <a:schemeClr val="tx1"/>
+        </a:solidFill>
+        <a:latin typeface="+mn-lt"/>
+        <a:ea typeface="+mn-ea"/>
+        <a:cs typeface="+mn-cs"/>
+      </a:defRPr>
+    </a:lvl1pPr>
+    <a:lvl2pPr marL="457200" algn="l" defTabSz="914400" rtl="0" eaLnBrk="1" latinLnBrk="0" hangingPunct="1">
+      <a:defRPr sz="1200" kern="1200">
+        <a:solidFill>
+          <a:schemeClr val="tx1"/>
+        </a:solidFill>
+        <a:latin typeface="+mn-lt"/>
+        <a:ea typeface="+mn-ea"/>
+        <a:cs typeface="+mn-cs"/>
+      </a:defRPr>
+    </a:lvl2pPr>
+    <a:lvl3pPr marL="914400" algn="l" defTabSz="914400" rtl="0" eaLnBrk="1" latinLnBrk="0" hangingPunct="1">
+      <a:defRPr sz="1200" kern="1200">
+        <a:solidFill>
+          <a:schemeClr val="tx1"/>
+        </a:solidFill>
+        <a:latin typeface="+mn-lt"/>
+        <a:ea typeface="+mn-ea"/>
+        <a:cs typeface="+mn-cs"/>
+      </a:defRPr>
+    </a:lvl3pPr>
+    <a:lvl4pPr marL="1371600" algn="l" defTabSz="914400" rtl="0" eaLnBrk="1" latinLnBrk="0" hangingPunct="1">
+      <a:defRPr sz="1200" kern="1200">
+        <a:solidFill>
+          <a:schemeClr val="tx1"/>
+        </a:solidFill>
+        <a:latin typeface="+mn-lt"/>
+        <a:ea typeface="+mn-ea"/>
+        <a:cs typeface="+mn-cs"/>
+      </a:defRPr>
+    </a:lvl4pPr>
+    <a:lvl5pPr marL="1828800" algn="l" defTabSz="914400" rtl="0" eaLnBrk="1" latinLnBrk="0" hangingPunct="1">
+      <a:defRPr sz="1200" kern="1200">
+        <a:solidFill>
+          <a:schemeClr val="tx1"/>
+        </a:solidFill>
+        <a:latin typeface="+mn-lt"/>
+        <a:ea typeface="+mn-ea"/>
+        <a:cs typeface="+mn-cs"/>
+      </a:defRPr>
+    </a:lvl5pPr>
+    <a:lvl6pPr marL="2286000" algn="l" defTabSz="914400" rtl="0" eaLnBrk="1" latinLnBrk="0" hangingPunct="1">
+      <a:defRPr sz="1200" kern="1200">
+        <a:solidFill>
+          <a:schemeClr val="tx1"/>
+        </a:solidFill>
+        <a:latin typeface="+mn-lt"/>
+        <a:ea typeface="+mn-ea"/>
+        <a:cs typeface="+mn-cs"/>
+      </a:defRPr>
+    </a:lvl6pPr>
+    <a:lvl7pPr marL="2743200" algn="l" defTabSz="914400" rtl="0" eaLnBrk="1" latinLnBrk="0" hangingPunct="1">
+      <a:defRPr sz="1200" kern="1200">
+        <a:solidFill>
+          <a:schemeClr val="tx1"/>
+        </a:solidFill>
+        <a:latin typeface="+mn-lt"/>
+        <a:ea typeface="+mn-ea"/>
+        <a:cs typeface="+mn-cs"/>
+      </a:defRPr>
+    </a:lvl7pPr>
+    <a:lvl8pPr marL="3200400" algn="l" defTabSz="914400" rtl="0" eaLnBrk="1" latinLnBrk="0" hangingPunct="1">
+      <a:defRPr sz="1200" kern="1200">
+        <a:solidFill>
+          <a:schemeClr val="tx1"/>
+        </a:solidFill>
+        <a:latin typeface="+mn-lt"/>
+        <a:ea typeface="+mn-ea"/>
+        <a:cs typeface="+mn-cs"/>
+      </a:defRPr>
+    </a:lvl8pPr>
+    <a:lvl9pPr marL="3657600" algn="l" defTabSz="914400" rtl="0" eaLnBrk="1" latinLnBrk="0" hangingPunct="1">
+      <a:defRPr sz="1200" kern="1200">
+        <a:solidFill>
+          <a:schemeClr val="tx1"/>
+        </a:solidFill>
+        <a:latin typeface="+mn-lt"/>
+        <a:ea typeface="+mn-ea"/>
+        <a:cs typeface="+mn-cs"/>
+      </a:defRPr>
+    </a:lvl9pPr>
+  </p:notesStyle>
+</p:notesMaster>
+</file>
+
+<file path=ppt/notesSlides/notesSlide1.xml><?xml version="1.0" encoding="utf-8"?>
+<p:notes xmlns:a="http://schemas.openxmlformats.org/drawingml/2006/main" xmlns:r="http://schemas.openxmlformats.org/officeDocument/2006/relationships" xmlns:p="http://schemas.openxmlformats.org/presentationml/2006/main">
+  <p:cSld>
+    <p:spTree>
+      <p:nvGrpSpPr>
+        <p:cNvPr id="1" name=""/>
+        <p:cNvGrpSpPr/>
+        <p:nvPr/>
+      </p:nvGrpSpPr>
+      <p:grpSpPr>
+        <a:xfrm>
+          <a:off x="0" y="0"/>
+          <a:ext cx="0" cy="0"/>
+          <a:chOff x="0" y="0"/>
+          <a:chExt cx="0" cy="0"/>
+        </a:xfrm>
+      </p:grpSpPr>
+      <p:sp>
+        <p:nvSpPr>
+          <p:cNvPr id="2" name="Slide Image Placeholder 1"/>
+          <p:cNvSpPr>
+            <a:spLocks noGrp="1" noRot="1" noChangeAspect="1"/>
+          </p:cNvSpPr>
+          <p:nvPr>
+            <p:ph type="sldImg"/>
+          </p:nvPr>
+        </p:nvSpPr>
+        <p:spPr/>
+      </p:sp>
+      <p:sp>
+        <p:nvSpPr>
+          <p:cNvPr id="3" name="Notes Placeholder 2"/>
+          <p:cNvSpPr>
+            <a:spLocks noGrp="1"/>
+          </p:cNvSpPr>
+          <p:nvPr>
+            <p:ph type="body" idx="1"/>
+          </p:nvPr>
+        </p:nvSpPr>
+        <p:spPr/>
+        <p:txBody>
+          <a:bodyPr/>
+          <a:lstStyle/>
+          <a:p>
+            <a:endParaRPr lang="en-GB" dirty="0"/>
+          </a:p>
+        </p:txBody>
+      </p:sp>
+      <p:sp>
+        <p:nvSpPr>
+          <p:cNvPr id="4" name="Slide Number Placeholder 3"/>
+          <p:cNvSpPr>
+            <a:spLocks noGrp="1"/>
+          </p:cNvSpPr>
+          <p:nvPr>
+            <p:ph type="sldNum" sz="quarter" idx="5"/>
+          </p:nvPr>
+        </p:nvSpPr>
+        <p:spPr/>
+        <p:txBody>
+          <a:bodyPr/>
+          <a:lstStyle/>
+          <a:p>
+            <a:fld id="{1CC3EDED-0833-4F63-A997-9302F708B90C}" type="slidenum">
+              <a:rPr lang="en-GB" smtClean="0"/>
+              <a:t>11</a:t>
+            </a:fld>
+            <a:endParaRPr lang="en-GB"/>
+          </a:p>
+        </p:txBody>
+      </p:sp>
+    </p:spTree>
+    <p:extLst>
+      <p:ext uri="{BB962C8B-B14F-4D97-AF65-F5344CB8AC3E}">
+        <p14:creationId xmlns:p14="http://schemas.microsoft.com/office/powerpoint/2010/main" val="3354561894"/>
+      </p:ext>
+    </p:extLst>
+  </p:cSld>
+  <p:clrMapOvr>
+    <a:masterClrMapping/>
+  </p:clrMapOvr>
+</p:notes>
+</file>
+
 <file path=ppt/slideLayouts/slideLayout1.xml><?xml version="1.0" encoding="utf-8"?>
 <p:sldLayout xmlns:a="http://schemas.openxmlformats.org/drawingml/2006/main" xmlns:r="http://schemas.openxmlformats.org/officeDocument/2006/relationships" xmlns:p="http://schemas.openxmlformats.org/presentationml/2006/main" type="title" preserve="1">
   <p:cSld name="Title Slide">
@@ -271,7 +711,7 @@
           <a:p>
             <a:fld id="{8727B1B5-114F-462F-9F43-A96471EB3E77}" type="datetimeFigureOut">
               <a:rPr lang="en-GB" smtClean="0"/>
-              <a:t>30/05/2026</a:t>
+              <a:t>31/05/2026</a:t>
             </a:fld>
             <a:endParaRPr lang="en-GB"/>
           </a:p>
@@ -471,7 +911,7 @@
           <a:p>
             <a:fld id="{8727B1B5-114F-462F-9F43-A96471EB3E77}" type="datetimeFigureOut">
               <a:rPr lang="en-GB" smtClean="0"/>
-              <a:t>30/05/2026</a:t>
+              <a:t>31/05/2026</a:t>
             </a:fld>
             <a:endParaRPr lang="en-GB"/>
           </a:p>
@@ -681,7 +1121,7 @@
           <a:p>
             <a:fld id="{8727B1B5-114F-462F-9F43-A96471EB3E77}" type="datetimeFigureOut">
               <a:rPr lang="en-GB" smtClean="0"/>
-              <a:t>30/05/2026</a:t>
+              <a:t>31/05/2026</a:t>
             </a:fld>
             <a:endParaRPr lang="en-GB"/>
           </a:p>
@@ -881,7 +1321,7 @@
           <a:p>
             <a:fld id="{8727B1B5-114F-462F-9F43-A96471EB3E77}" type="datetimeFigureOut">
               <a:rPr lang="en-GB" smtClean="0"/>
-              <a:t>30/05/2026</a:t>
+              <a:t>31/05/2026</a:t>
             </a:fld>
             <a:endParaRPr lang="en-GB"/>
           </a:p>
@@ -1157,7 +1597,7 @@
           <a:p>
             <a:fld id="{8727B1B5-114F-462F-9F43-A96471EB3E77}" type="datetimeFigureOut">
               <a:rPr lang="en-GB" smtClean="0"/>
-              <a:t>30/05/2026</a:t>
+              <a:t>31/05/2026</a:t>
             </a:fld>
             <a:endParaRPr lang="en-GB"/>
           </a:p>
@@ -1425,7 +1865,7 @@
           <a:p>
             <a:fld id="{8727B1B5-114F-462F-9F43-A96471EB3E77}" type="datetimeFigureOut">
               <a:rPr lang="en-GB" smtClean="0"/>
-              <a:t>30/05/2026</a:t>
+              <a:t>31/05/2026</a:t>
             </a:fld>
             <a:endParaRPr lang="en-GB"/>
           </a:p>
@@ -1840,7 +2280,7 @@
           <a:p>
             <a:fld id="{8727B1B5-114F-462F-9F43-A96471EB3E77}" type="datetimeFigureOut">
               <a:rPr lang="en-GB" smtClean="0"/>
-              <a:t>30/05/2026</a:t>
+              <a:t>31/05/2026</a:t>
             </a:fld>
             <a:endParaRPr lang="en-GB"/>
           </a:p>
@@ -1982,7 +2422,7 @@
           <a:p>
             <a:fld id="{8727B1B5-114F-462F-9F43-A96471EB3E77}" type="datetimeFigureOut">
               <a:rPr lang="en-GB" smtClean="0"/>
-              <a:t>30/05/2026</a:t>
+              <a:t>31/05/2026</a:t>
             </a:fld>
             <a:endParaRPr lang="en-GB"/>
           </a:p>
@@ -2095,7 +2535,7 @@
           <a:p>
             <a:fld id="{8727B1B5-114F-462F-9F43-A96471EB3E77}" type="datetimeFigureOut">
               <a:rPr lang="en-GB" smtClean="0"/>
-              <a:t>30/05/2026</a:t>
+              <a:t>31/05/2026</a:t>
             </a:fld>
             <a:endParaRPr lang="en-GB"/>
           </a:p>
@@ -2408,7 +2848,7 @@
           <a:p>
             <a:fld id="{8727B1B5-114F-462F-9F43-A96471EB3E77}" type="datetimeFigureOut">
               <a:rPr lang="en-GB" smtClean="0"/>
-              <a:t>30/05/2026</a:t>
+              <a:t>31/05/2026</a:t>
             </a:fld>
             <a:endParaRPr lang="en-GB"/>
           </a:p>
@@ -2697,7 +3137,7 @@
           <a:p>
             <a:fld id="{8727B1B5-114F-462F-9F43-A96471EB3E77}" type="datetimeFigureOut">
               <a:rPr lang="en-GB" smtClean="0"/>
-              <a:t>30/05/2026</a:t>
+              <a:t>31/05/2026</a:t>
             </a:fld>
             <a:endParaRPr lang="en-GB"/>
           </a:p>
@@ -2940,7 +3380,7 @@
           <a:p>
             <a:fld id="{8727B1B5-114F-462F-9F43-A96471EB3E77}" type="datetimeFigureOut">
               <a:rPr lang="en-GB" smtClean="0"/>
-              <a:t>30/05/2026</a:t>
+              <a:t>31/05/2026</a:t>
             </a:fld>
             <a:endParaRPr lang="en-GB"/>
           </a:p>
@@ -3537,6 +3977,565 @@
           <p:cNvPr id="3" name="TextBox 2">
             <a:extLst>
               <a:ext uri="{FF2B5EF4-FFF2-40B4-BE49-F238E27FC236}">
+                <a16:creationId xmlns:a16="http://schemas.microsoft.com/office/drawing/2014/main" id="{9E4477BC-B009-9F2D-792B-5ABADDF67C8C}"/>
+              </a:ext>
+            </a:extLst>
+          </p:cNvPr>
+          <p:cNvSpPr txBox="1"/>
+          <p:nvPr/>
+        </p:nvSpPr>
+        <p:spPr>
+          <a:xfrm>
+            <a:off x="7639665" y="2396131"/>
+            <a:ext cx="6096000" cy="2400657"/>
+          </a:xfrm>
+          <a:prstGeom prst="rect">
+            <a:avLst/>
+          </a:prstGeom>
+          <a:noFill/>
+        </p:spPr>
+        <p:txBody>
+          <a:bodyPr wrap="square">
+            <a:spAutoFit/>
+          </a:bodyPr>
+          <a:lstStyle/>
+          <a:p>
+            <a:r>
+              <a:rPr lang="en-GB" sz="3200" b="1" dirty="0"/>
+              <a:t>Exploratory Data Analysis</a:t>
+            </a:r>
+          </a:p>
+          <a:p>
+            <a:endParaRPr lang="en-GB" dirty="0"/>
+          </a:p>
+          <a:p>
+            <a:r>
+              <a:rPr lang="en-GB" sz="2000" dirty="0"/>
+              <a:t>• Disease distribution analysis.</a:t>
+            </a:r>
+          </a:p>
+          <a:p>
+            <a:r>
+              <a:rPr lang="en-GB" sz="2000" dirty="0"/>
+              <a:t>• Gender and city-wise analysis.</a:t>
+            </a:r>
+          </a:p>
+          <a:p>
+            <a:r>
+              <a:rPr lang="en-GB" sz="2000" dirty="0"/>
+              <a:t>• Admission status analysis.</a:t>
+            </a:r>
+          </a:p>
+          <a:p>
+            <a:r>
+              <a:rPr lang="en-GB" sz="2000" dirty="0"/>
+              <a:t>• Treatment cost statistics.</a:t>
+            </a:r>
+          </a:p>
+          <a:p>
+            <a:r>
+              <a:rPr lang="en-GB" sz="2000" dirty="0"/>
+              <a:t>• Generated healthcare insights.</a:t>
+            </a:r>
+          </a:p>
+        </p:txBody>
+      </p:sp>
+      <p:pic>
+        <p:nvPicPr>
+          <p:cNvPr id="5" name="Picture 4">
+            <a:extLst>
+              <a:ext uri="{FF2B5EF4-FFF2-40B4-BE49-F238E27FC236}">
+                <a16:creationId xmlns:a16="http://schemas.microsoft.com/office/drawing/2014/main" id="{AB95E666-E490-C7ED-937D-DC532D93691F}"/>
+              </a:ext>
+            </a:extLst>
+          </p:cNvPr>
+          <p:cNvPicPr>
+            <a:picLocks noChangeAspect="1"/>
+          </p:cNvPicPr>
+          <p:nvPr/>
+        </p:nvPicPr>
+        <p:blipFill>
+          <a:blip r:embed="rId2">
+            <a:extLst>
+              <a:ext uri="{28A0092B-C50C-407E-A947-70E740481C1C}">
+                <a14:useLocalDpi xmlns:a14="http://schemas.microsoft.com/office/drawing/2010/main" val="0"/>
+              </a:ext>
+            </a:extLst>
+          </a:blip>
+          <a:stretch>
+            <a:fillRect/>
+          </a:stretch>
+        </p:blipFill>
+        <p:spPr>
+          <a:xfrm>
+            <a:off x="168130" y="247650"/>
+            <a:ext cx="7373211" cy="6362700"/>
+          </a:xfrm>
+          <a:prstGeom prst="rect">
+            <a:avLst/>
+          </a:prstGeom>
+          <a:solidFill>
+            <a:srgbClr val="FFFFFF">
+              <a:shade val="85000"/>
+            </a:srgbClr>
+          </a:solidFill>
+          <a:ln w="88900" cap="sq">
+            <a:solidFill>
+              <a:srgbClr val="FFFFFF"/>
+            </a:solidFill>
+            <a:miter lim="800000"/>
+          </a:ln>
+          <a:effectLst>
+            <a:outerShdw blurRad="55000" dist="18000" dir="5400000" algn="tl" rotWithShape="0">
+              <a:srgbClr val="000000">
+                <a:alpha val="40000"/>
+              </a:srgbClr>
+            </a:outerShdw>
+          </a:effectLst>
+          <a:scene3d>
+            <a:camera prst="orthographicFront"/>
+            <a:lightRig rig="twoPt" dir="t">
+              <a:rot lat="0" lon="0" rev="7200000"/>
+            </a:lightRig>
+          </a:scene3d>
+          <a:sp3d>
+            <a:bevelT w="25400" h="19050"/>
+            <a:contourClr>
+              <a:srgbClr val="FFFFFF"/>
+            </a:contourClr>
+          </a:sp3d>
+        </p:spPr>
+      </p:pic>
+    </p:spTree>
+    <p:extLst>
+      <p:ext uri="{BB962C8B-B14F-4D97-AF65-F5344CB8AC3E}">
+        <p14:creationId xmlns:p14="http://schemas.microsoft.com/office/powerpoint/2010/main" val="1555976044"/>
+      </p:ext>
+    </p:extLst>
+  </p:cSld>
+  <p:clrMapOvr>
+    <a:masterClrMapping/>
+  </p:clrMapOvr>
+</p:sld>
+</file>
+
+<file path=ppt/slides/slide11.xml><?xml version="1.0" encoding="utf-8"?>
+<p:sld xmlns:a="http://schemas.openxmlformats.org/drawingml/2006/main" xmlns:r="http://schemas.openxmlformats.org/officeDocument/2006/relationships" xmlns:p="http://schemas.openxmlformats.org/presentationml/2006/main">
+  <p:cSld>
+    <p:spTree>
+      <p:nvGrpSpPr>
+        <p:cNvPr id="1" name=""/>
+        <p:cNvGrpSpPr/>
+        <p:nvPr/>
+      </p:nvGrpSpPr>
+      <p:grpSpPr>
+        <a:xfrm>
+          <a:off x="0" y="0"/>
+          <a:ext cx="0" cy="0"/>
+          <a:chOff x="0" y="0"/>
+          <a:chExt cx="0" cy="0"/>
+        </a:xfrm>
+      </p:grpSpPr>
+      <p:sp>
+        <p:nvSpPr>
+          <p:cNvPr id="3" name="TextBox 2">
+            <a:extLst>
+              <a:ext uri="{FF2B5EF4-FFF2-40B4-BE49-F238E27FC236}">
+                <a16:creationId xmlns:a16="http://schemas.microsoft.com/office/drawing/2014/main" id="{4BB448C2-9C61-238F-4940-6D285C14ED9C}"/>
+              </a:ext>
+            </a:extLst>
+          </p:cNvPr>
+          <p:cNvSpPr txBox="1"/>
+          <p:nvPr/>
+        </p:nvSpPr>
+        <p:spPr>
+          <a:xfrm>
+            <a:off x="680022" y="5051687"/>
+            <a:ext cx="4324596" cy="1354217"/>
+          </a:xfrm>
+          <a:prstGeom prst="rect">
+            <a:avLst/>
+          </a:prstGeom>
+          <a:noFill/>
+        </p:spPr>
+        <p:txBody>
+          <a:bodyPr wrap="square">
+            <a:spAutoFit/>
+          </a:bodyPr>
+          <a:lstStyle/>
+          <a:p>
+            <a:r>
+              <a:rPr lang="en-GB" sz="3200" b="1" dirty="0"/>
+              <a:t>Machine Learning Model</a:t>
+            </a:r>
+          </a:p>
+          <a:p>
+            <a:endParaRPr lang="en-GB" dirty="0"/>
+          </a:p>
+        </p:txBody>
+      </p:sp>
+      <p:pic>
+        <p:nvPicPr>
+          <p:cNvPr id="5" name="Picture 4">
+            <a:extLst>
+              <a:ext uri="{FF2B5EF4-FFF2-40B4-BE49-F238E27FC236}">
+                <a16:creationId xmlns:a16="http://schemas.microsoft.com/office/drawing/2014/main" id="{A5D5C314-CBCF-CD42-FD1D-5ED2C119DB95}"/>
+              </a:ext>
+            </a:extLst>
+          </p:cNvPr>
+          <p:cNvPicPr>
+            <a:picLocks noChangeAspect="1"/>
+          </p:cNvPicPr>
+          <p:nvPr/>
+        </p:nvPicPr>
+        <p:blipFill>
+          <a:blip r:embed="rId3">
+            <a:extLst>
+              <a:ext uri="{28A0092B-C50C-407E-A947-70E740481C1C}">
+                <a14:useLocalDpi xmlns:a14="http://schemas.microsoft.com/office/drawing/2010/main" val="0"/>
+              </a:ext>
+            </a:extLst>
+          </a:blip>
+          <a:stretch>
+            <a:fillRect/>
+          </a:stretch>
+        </p:blipFill>
+        <p:spPr>
+          <a:xfrm>
+            <a:off x="286733" y="286034"/>
+            <a:ext cx="11472648" cy="3723433"/>
+          </a:xfrm>
+          <a:prstGeom prst="rect">
+            <a:avLst/>
+          </a:prstGeom>
+          <a:solidFill>
+            <a:srgbClr val="FFFFFF">
+              <a:shade val="85000"/>
+            </a:srgbClr>
+          </a:solidFill>
+          <a:ln w="88900" cap="sq">
+            <a:solidFill>
+              <a:srgbClr val="FFFFFF"/>
+            </a:solidFill>
+            <a:miter lim="800000"/>
+          </a:ln>
+          <a:effectLst>
+            <a:outerShdw blurRad="55000" dist="18000" dir="5400000" algn="tl" rotWithShape="0">
+              <a:srgbClr val="000000">
+                <a:alpha val="40000"/>
+              </a:srgbClr>
+            </a:outerShdw>
+          </a:effectLst>
+          <a:scene3d>
+            <a:camera prst="orthographicFront"/>
+            <a:lightRig rig="twoPt" dir="t">
+              <a:rot lat="0" lon="0" rev="7200000"/>
+            </a:lightRig>
+          </a:scene3d>
+          <a:sp3d>
+            <a:bevelT w="25400" h="19050"/>
+            <a:contourClr>
+              <a:srgbClr val="FFFFFF"/>
+            </a:contourClr>
+          </a:sp3d>
+        </p:spPr>
+      </p:pic>
+      <p:sp>
+        <p:nvSpPr>
+          <p:cNvPr id="4" name="TextBox 3">
+            <a:extLst>
+              <a:ext uri="{FF2B5EF4-FFF2-40B4-BE49-F238E27FC236}">
+                <a16:creationId xmlns:a16="http://schemas.microsoft.com/office/drawing/2014/main" id="{3A475FCB-EE74-3C6C-AC91-FDF15EC93828}"/>
+              </a:ext>
+            </a:extLst>
+          </p:cNvPr>
+          <p:cNvSpPr txBox="1"/>
+          <p:nvPr/>
+        </p:nvSpPr>
+        <p:spPr>
+          <a:xfrm>
+            <a:off x="6023057" y="4725490"/>
+            <a:ext cx="6096000" cy="1323439"/>
+          </a:xfrm>
+          <a:prstGeom prst="rect">
+            <a:avLst/>
+          </a:prstGeom>
+          <a:noFill/>
+        </p:spPr>
+        <p:txBody>
+          <a:bodyPr wrap="square">
+            <a:spAutoFit/>
+          </a:bodyPr>
+          <a:lstStyle/>
+          <a:p>
+            <a:r>
+              <a:rPr lang="en-GB" sz="2000" dirty="0"/>
+              <a:t>• Random Forest Regressor implemented.</a:t>
+            </a:r>
+          </a:p>
+          <a:p>
+            <a:r>
+              <a:rPr lang="en-GB" sz="2000" dirty="0"/>
+              <a:t>• Treatment cost prediction performed.</a:t>
+            </a:r>
+          </a:p>
+          <a:p>
+            <a:r>
+              <a:rPr lang="en-GB" sz="2000" dirty="0"/>
+              <a:t>• Model trained on healthcare dataset.</a:t>
+            </a:r>
+          </a:p>
+          <a:p>
+            <a:r>
+              <a:rPr lang="en-GB" sz="2000" dirty="0"/>
+              <a:t>• Performance evaluated using MAE.</a:t>
+            </a:r>
+          </a:p>
+        </p:txBody>
+      </p:sp>
+    </p:spTree>
+    <p:extLst>
+      <p:ext uri="{BB962C8B-B14F-4D97-AF65-F5344CB8AC3E}">
+        <p14:creationId xmlns:p14="http://schemas.microsoft.com/office/powerpoint/2010/main" val="2032054767"/>
+      </p:ext>
+    </p:extLst>
+  </p:cSld>
+  <p:clrMapOvr>
+    <a:masterClrMapping/>
+  </p:clrMapOvr>
+</p:sld>
+</file>
+
+<file path=ppt/slides/slide12.xml><?xml version="1.0" encoding="utf-8"?>
+<p:sld xmlns:a="http://schemas.openxmlformats.org/drawingml/2006/main" xmlns:r="http://schemas.openxmlformats.org/officeDocument/2006/relationships" xmlns:p="http://schemas.openxmlformats.org/presentationml/2006/main">
+  <p:cSld>
+    <p:spTree>
+      <p:nvGrpSpPr>
+        <p:cNvPr id="1" name=""/>
+        <p:cNvGrpSpPr/>
+        <p:nvPr/>
+      </p:nvGrpSpPr>
+      <p:grpSpPr>
+        <a:xfrm>
+          <a:off x="0" y="0"/>
+          <a:ext cx="0" cy="0"/>
+          <a:chOff x="0" y="0"/>
+          <a:chExt cx="0" cy="0"/>
+        </a:xfrm>
+      </p:grpSpPr>
+      <p:sp>
+        <p:nvSpPr>
+          <p:cNvPr id="3" name="TextBox 2">
+            <a:extLst>
+              <a:ext uri="{FF2B5EF4-FFF2-40B4-BE49-F238E27FC236}">
+                <a16:creationId xmlns:a16="http://schemas.microsoft.com/office/drawing/2014/main" id="{703B2267-BFCE-66E7-D000-E9D18EEFD2A0}"/>
+              </a:ext>
+            </a:extLst>
+          </p:cNvPr>
+          <p:cNvSpPr txBox="1"/>
+          <p:nvPr/>
+        </p:nvSpPr>
+        <p:spPr>
+          <a:xfrm>
+            <a:off x="779206" y="4844210"/>
+            <a:ext cx="6096000" cy="1077218"/>
+          </a:xfrm>
+          <a:prstGeom prst="rect">
+            <a:avLst/>
+          </a:prstGeom>
+          <a:noFill/>
+        </p:spPr>
+        <p:txBody>
+          <a:bodyPr wrap="square">
+            <a:spAutoFit/>
+          </a:bodyPr>
+          <a:lstStyle/>
+          <a:p>
+            <a:r>
+              <a:rPr lang="en-GB" sz="3200" b="1" dirty="0"/>
+              <a:t>CI/CD Automation using</a:t>
+            </a:r>
+          </a:p>
+          <a:p>
+            <a:r>
+              <a:rPr lang="en-GB" sz="3200" b="1" dirty="0"/>
+              <a:t>GitHub Actions</a:t>
+            </a:r>
+          </a:p>
+        </p:txBody>
+      </p:sp>
+      <p:sp>
+        <p:nvSpPr>
+          <p:cNvPr id="5" name="TextBox 4">
+            <a:extLst>
+              <a:ext uri="{FF2B5EF4-FFF2-40B4-BE49-F238E27FC236}">
+                <a16:creationId xmlns:a16="http://schemas.microsoft.com/office/drawing/2014/main" id="{94D172F4-AB06-A8D1-F0F8-223E1C869729}"/>
+              </a:ext>
+            </a:extLst>
+          </p:cNvPr>
+          <p:cNvSpPr txBox="1"/>
+          <p:nvPr/>
+        </p:nvSpPr>
+        <p:spPr>
+          <a:xfrm>
+            <a:off x="5665837" y="4377422"/>
+            <a:ext cx="6456108" cy="2246769"/>
+          </a:xfrm>
+          <a:prstGeom prst="rect">
+            <a:avLst/>
+          </a:prstGeom>
+          <a:noFill/>
+        </p:spPr>
+        <p:txBody>
+          <a:bodyPr wrap="square">
+            <a:spAutoFit/>
+          </a:bodyPr>
+          <a:lstStyle/>
+          <a:p>
+            <a:r>
+              <a:rPr lang="en-GB" sz="2000" dirty="0"/>
+              <a:t>• GitHub Actions workflow implemented</a:t>
+            </a:r>
+          </a:p>
+          <a:p>
+            <a:r>
+              <a:rPr lang="en-GB" sz="2000" dirty="0"/>
+              <a:t>• Automated code validation and execution</a:t>
+            </a:r>
+          </a:p>
+          <a:p>
+            <a:r>
+              <a:rPr lang="en-GB" sz="2000" dirty="0"/>
+              <a:t>• Continuous Integration (CI) pipeline</a:t>
+            </a:r>
+          </a:p>
+          <a:p>
+            <a:r>
+              <a:rPr lang="en-GB" sz="2000" dirty="0"/>
+              <a:t>• Automatic workflow execution on </a:t>
+            </a:r>
+          </a:p>
+          <a:p>
+            <a:r>
+              <a:rPr lang="en-GB" sz="2000" dirty="0"/>
+              <a:t>   code updates</a:t>
+            </a:r>
+          </a:p>
+          <a:p>
+            <a:r>
+              <a:rPr lang="en-GB" sz="2000" dirty="0"/>
+              <a:t>• Improved deployment and maintenance </a:t>
+            </a:r>
+          </a:p>
+          <a:p>
+            <a:r>
+              <a:rPr lang="en-GB" sz="2000" dirty="0"/>
+              <a:t>   readiness</a:t>
+            </a:r>
+          </a:p>
+        </p:txBody>
+      </p:sp>
+      <p:pic>
+        <p:nvPicPr>
+          <p:cNvPr id="7" name="Picture 6">
+            <a:extLst>
+              <a:ext uri="{FF2B5EF4-FFF2-40B4-BE49-F238E27FC236}">
+                <a16:creationId xmlns:a16="http://schemas.microsoft.com/office/drawing/2014/main" id="{37ACE042-9936-B330-8F17-E45C9F244C13}"/>
+              </a:ext>
+            </a:extLst>
+          </p:cNvPr>
+          <p:cNvPicPr>
+            <a:picLocks noChangeAspect="1"/>
+          </p:cNvPicPr>
+          <p:nvPr/>
+        </p:nvPicPr>
+        <p:blipFill>
+          <a:blip r:embed="rId2">
+            <a:extLst>
+              <a:ext uri="{28A0092B-C50C-407E-A947-70E740481C1C}">
+                <a14:useLocalDpi xmlns:a14="http://schemas.microsoft.com/office/drawing/2010/main" val="0"/>
+              </a:ext>
+            </a:extLst>
+          </a:blip>
+          <a:stretch>
+            <a:fillRect/>
+          </a:stretch>
+        </p:blipFill>
+        <p:spPr>
+          <a:xfrm>
+            <a:off x="70054" y="139602"/>
+            <a:ext cx="12051891" cy="4082672"/>
+          </a:xfrm>
+          <a:prstGeom prst="rect">
+            <a:avLst/>
+          </a:prstGeom>
+          <a:solidFill>
+            <a:srgbClr val="FFFFFF">
+              <a:shade val="85000"/>
+            </a:srgbClr>
+          </a:solidFill>
+          <a:ln w="88900" cap="sq">
+            <a:solidFill>
+              <a:srgbClr val="FFFFFF"/>
+            </a:solidFill>
+            <a:miter lim="800000"/>
+          </a:ln>
+          <a:effectLst>
+            <a:outerShdw blurRad="55000" dist="18000" dir="5400000" algn="tl" rotWithShape="0">
+              <a:srgbClr val="000000">
+                <a:alpha val="40000"/>
+              </a:srgbClr>
+            </a:outerShdw>
+          </a:effectLst>
+          <a:scene3d>
+            <a:camera prst="orthographicFront"/>
+            <a:lightRig rig="twoPt" dir="t">
+              <a:rot lat="0" lon="0" rev="7200000"/>
+            </a:lightRig>
+          </a:scene3d>
+          <a:sp3d>
+            <a:bevelT w="25400" h="19050"/>
+            <a:contourClr>
+              <a:srgbClr val="FFFFFF"/>
+            </a:contourClr>
+          </a:sp3d>
+        </p:spPr>
+      </p:pic>
+    </p:spTree>
+    <p:extLst>
+      <p:ext uri="{BB962C8B-B14F-4D97-AF65-F5344CB8AC3E}">
+        <p14:creationId xmlns:p14="http://schemas.microsoft.com/office/powerpoint/2010/main" val="1395221662"/>
+      </p:ext>
+    </p:extLst>
+  </p:cSld>
+  <p:clrMapOvr>
+    <a:masterClrMapping/>
+  </p:clrMapOvr>
+</p:sld>
+</file>
+
+<file path=ppt/slides/slide13.xml><?xml version="1.0" encoding="utf-8"?>
+<p:sld xmlns:a="http://schemas.openxmlformats.org/drawingml/2006/main" xmlns:r="http://schemas.openxmlformats.org/officeDocument/2006/relationships" xmlns:p="http://schemas.openxmlformats.org/presentationml/2006/main">
+  <p:cSld>
+    <p:spTree>
+      <p:nvGrpSpPr>
+        <p:cNvPr id="1" name=""/>
+        <p:cNvGrpSpPr/>
+        <p:nvPr/>
+      </p:nvGrpSpPr>
+      <p:grpSpPr>
+        <a:xfrm>
+          <a:off x="0" y="0"/>
+          <a:ext cx="0" cy="0"/>
+          <a:chOff x="0" y="0"/>
+          <a:chExt cx="0" cy="0"/>
+        </a:xfrm>
+      </p:grpSpPr>
+      <p:sp>
+        <p:nvSpPr>
+          <p:cNvPr id="3" name="TextBox 2">
+            <a:extLst>
+              <a:ext uri="{FF2B5EF4-FFF2-40B4-BE49-F238E27FC236}">
                 <a16:creationId xmlns:a16="http://schemas.microsoft.com/office/drawing/2014/main" id="{BC28EFC9-B009-31E0-2BFA-83B6ADC518C1}"/>
               </a:ext>
             </a:extLst>
@@ -3561,7 +4560,7 @@
           <a:lstStyle/>
           <a:p>
             <a:r>
-              <a:rPr lang="en-US" sz="3200" dirty="0"/>
+              <a:rPr lang="en-US" sz="3200" b="1" dirty="0"/>
               <a:t>Interactive Dashboard</a:t>
             </a:r>
           </a:p>
@@ -3733,7 +4732,7 @@
 </p:sld>
 </file>
 
-<file path=ppt/slides/slide11.xml><?xml version="1.0" encoding="utf-8"?>
+<file path=ppt/slides/slide14.xml><?xml version="1.0" encoding="utf-8"?>
 <p:sld xmlns:a="http://schemas.openxmlformats.org/drawingml/2006/main" xmlns:r="http://schemas.openxmlformats.org/officeDocument/2006/relationships" xmlns:p="http://schemas.openxmlformats.org/presentationml/2006/main">
   <p:cSld>
     <p:spTree>
@@ -3764,8 +4763,8 @@
         </p:nvSpPr>
         <p:spPr>
           <a:xfrm>
-            <a:off x="1061884" y="874334"/>
-            <a:ext cx="6096000" cy="5324535"/>
+            <a:off x="1081549" y="458956"/>
+            <a:ext cx="6096000" cy="6093976"/>
           </a:xfrm>
           <a:prstGeom prst="rect">
             <a:avLst/>
@@ -3779,7 +4778,7 @@
           <a:lstStyle/>
           <a:p>
             <a:r>
-              <a:rPr lang="en-GB" sz="3200" dirty="0"/>
+              <a:rPr lang="en-GB" sz="3200" b="1" dirty="0"/>
               <a:t>Conclusion &amp; Future Scope</a:t>
             </a:r>
           </a:p>
@@ -3795,8 +4794,19 @@
           <a:p>
             <a:r>
               <a:rPr lang="en-GB" sz="2000" dirty="0"/>
-              <a:t>• Integrated AWS S3, Airflow, PySpark and PostgreSQL.</a:t>
-            </a:r>
+              <a:t>• </a:t>
+            </a:r>
+            <a:r>
+              <a:rPr lang="en-US" sz="2000" dirty="0"/>
+              <a:t>Integrated AWS S3, Apache Kafka, Databricks, </a:t>
+            </a:r>
+          </a:p>
+          <a:p>
+            <a:r>
+              <a:rPr lang="en-US" sz="2000" dirty="0"/>
+              <a:t>   Airflow, PySpark and PostgreSQL.</a:t>
+            </a:r>
+            <a:endParaRPr lang="en-GB" sz="2000" dirty="0"/>
           </a:p>
           <a:p>
             <a:r>
@@ -3817,11 +4827,18 @@
             </a:r>
           </a:p>
           <a:p>
+            <a:r>
+              <a:rPr lang="en-US" sz="2000" dirty="0"/>
+              <a:t>• Implemented GitHub Actions based CI/CD workflow.</a:t>
+            </a:r>
+            <a:endParaRPr lang="en-GB" sz="2000" dirty="0"/>
+          </a:p>
+          <a:p>
             <a:endParaRPr lang="en-GB" dirty="0"/>
           </a:p>
           <a:p>
             <a:r>
-              <a:rPr lang="en-GB" sz="3200" dirty="0"/>
+              <a:rPr lang="en-GB" sz="3200" b="1" dirty="0"/>
               <a:t>Future Scope</a:t>
             </a:r>
           </a:p>
@@ -3830,34 +4847,34 @@
           </a:p>
           <a:p>
             <a:r>
-              <a:rPr lang="en-GB" sz="2000" dirty="0"/>
-              <a:t>• Real-time healthcare data processing.</a:t>
-            </a:r>
-          </a:p>
-          <a:p>
-            <a:r>
-              <a:rPr lang="en-GB" sz="2000" dirty="0"/>
-              <a:t>• Advanced predictive analytics.</a:t>
-            </a:r>
-          </a:p>
-          <a:p>
-            <a:r>
-              <a:rPr lang="en-GB" sz="2000" dirty="0"/>
-              <a:t>• Integration with hospital information systems.</a:t>
-            </a:r>
-          </a:p>
-          <a:p>
-            <a:r>
-              <a:rPr lang="en-GB" sz="2000" dirty="0"/>
-              <a:t>• Enterprise-scale cloud deployment.</a:t>
-            </a:r>
-          </a:p>
-          <a:p>
-            <a:endParaRPr lang="en-GB" dirty="0"/>
-          </a:p>
-          <a:p>
-            <a:r>
-              <a:rPr lang="en-GB" sz="2400" dirty="0"/>
+              <a:rPr lang="en-US" sz="2000" dirty="0"/>
+              <a:t>• Snowflake Data Warehouse integration</a:t>
+            </a:r>
+          </a:p>
+          <a:p>
+            <a:r>
+              <a:rPr lang="en-US" sz="2000" dirty="0"/>
+              <a:t>• Kubernetes-based container orchestration</a:t>
+            </a:r>
+          </a:p>
+          <a:p>
+            <a:r>
+              <a:rPr lang="en-US" sz="2000" dirty="0"/>
+              <a:t>• Advanced predictive analytics</a:t>
+            </a:r>
+          </a:p>
+          <a:p>
+            <a:r>
+              <a:rPr lang="en-US" sz="2000" dirty="0"/>
+              <a:t>• Integration with hospital information systems</a:t>
+            </a:r>
+          </a:p>
+          <a:p>
+            <a:endParaRPr lang="en-GB" sz="2000" dirty="0"/>
+          </a:p>
+          <a:p>
+            <a:r>
+              <a:rPr lang="en-GB" sz="3200" b="1" dirty="0"/>
               <a:t>Thank You</a:t>
             </a:r>
           </a:p>
@@ -3922,7 +4939,7 @@
           <a:lstStyle/>
           <a:p>
             <a:r>
-              <a:rPr lang="en-GB" sz="3200" dirty="0"/>
+              <a:rPr lang="en-GB" sz="3200" b="1" dirty="0"/>
               <a:t>Problem Statement</a:t>
             </a:r>
           </a:p>
@@ -3964,7 +4981,7 @@
           </a:p>
           <a:p>
             <a:r>
-              <a:rPr lang="en-GB" sz="3200" dirty="0"/>
+              <a:rPr lang="en-GB" sz="3200" b="1" dirty="0"/>
               <a:t>Objective</a:t>
             </a:r>
           </a:p>
@@ -4045,7 +5062,7 @@
         <p:spPr>
           <a:xfrm>
             <a:off x="6027174" y="1197620"/>
-            <a:ext cx="6096000" cy="4462760"/>
+            <a:ext cx="6096000" cy="3539430"/>
           </a:xfrm>
           <a:prstGeom prst="rect">
             <a:avLst/>
@@ -4069,37 +5086,49 @@
           <a:p>
             <a:r>
               <a:rPr lang="en-US" sz="2000" dirty="0"/>
-              <a:t>• Cloud-based end-to-end healthcare analytics pipeline.</a:t>
+              <a:t>• Cloud-based end-to-end analytics pipeline</a:t>
             </a:r>
           </a:p>
           <a:p>
             <a:r>
               <a:rPr lang="en-US" sz="2000" dirty="0"/>
-              <a:t>• Automated ETL processing and workflow orchestration             using Apache Airflow.</a:t>
+              <a:t>• Real-time streaming capability using Apache Kafka</a:t>
             </a:r>
           </a:p>
           <a:p>
             <a:r>
               <a:rPr lang="en-US" sz="2000" dirty="0"/>
-              <a:t>• Scalable big data processing and analytics using PySpark.</a:t>
+              <a:t>• Databricks-powered PySpark processing</a:t>
             </a:r>
           </a:p>
           <a:p>
             <a:r>
               <a:rPr lang="en-US" sz="2000" dirty="0"/>
-              <a:t>• Star Schema Data Warehouse for analytical reporting     and SQL-based insights.</a:t>
+              <a:t>• Automated workflow orchestration using Airflow</a:t>
             </a:r>
           </a:p>
           <a:p>
             <a:r>
               <a:rPr lang="en-US" sz="2000" dirty="0"/>
-              <a:t>• Machine Learning layer for predictive analytics and Length of Stay prediction.</a:t>
+              <a:t>• Star Schema Data Warehouse for analytics</a:t>
             </a:r>
           </a:p>
           <a:p>
             <a:r>
               <a:rPr lang="en-US" sz="2000" dirty="0"/>
-              <a:t>• Interactive Streamlit dashboard for KPI monitoring, visualization, and reporting.</a:t>
+              <a:t>• Machine Learning based predictive analytics</a:t>
+            </a:r>
+          </a:p>
+          <a:p>
+            <a:r>
+              <a:rPr lang="en-US" sz="2000" dirty="0"/>
+              <a:t>• CI/CD automation using GitHub Actions</a:t>
+            </a:r>
+          </a:p>
+          <a:p>
+            <a:r>
+              <a:rPr lang="en-US" sz="2000" dirty="0"/>
+              <a:t>• Interactive Streamlit dashboard for reporting</a:t>
             </a:r>
             <a:endParaRPr lang="en-GB" sz="2000" dirty="0"/>
           </a:p>
@@ -4107,10 +5136,10 @@
       </p:sp>
       <p:pic>
         <p:nvPicPr>
-          <p:cNvPr id="2" name="Picture 1">
-            <a:extLst>
-              <a:ext uri="{FF2B5EF4-FFF2-40B4-BE49-F238E27FC236}">
-                <a16:creationId xmlns:a16="http://schemas.microsoft.com/office/drawing/2014/main" id="{38EA2E30-05B9-8A3E-BB1E-B7DD1698D3DA}"/>
+          <p:cNvPr id="4" name="Picture 3">
+            <a:extLst>
+              <a:ext uri="{FF2B5EF4-FFF2-40B4-BE49-F238E27FC236}">
+                <a16:creationId xmlns:a16="http://schemas.microsoft.com/office/drawing/2014/main" id="{147C65BD-CB16-3B70-AAB3-3E8AD15ABBDE}"/>
               </a:ext>
             </a:extLst>
           </p:cNvPr>
@@ -4133,8 +5162,8 @@
         </p:blipFill>
         <p:spPr>
           <a:xfrm>
-            <a:off x="167148" y="169607"/>
-            <a:ext cx="5633720" cy="6518786"/>
+            <a:off x="380999" y="167148"/>
+            <a:ext cx="5538020" cy="6449962"/>
           </a:xfrm>
           <a:prstGeom prst="rect">
             <a:avLst/>
@@ -4373,8 +5402,8 @@
         </p:nvSpPr>
         <p:spPr>
           <a:xfrm>
-            <a:off x="6902246" y="3498110"/>
-            <a:ext cx="6096000" cy="2400657"/>
+            <a:off x="6902246" y="3742526"/>
+            <a:ext cx="5034115" cy="2893100"/>
           </a:xfrm>
           <a:prstGeom prst="rect">
             <a:avLst/>
@@ -4388,8 +5417,8 @@
           <a:lstStyle/>
           <a:p>
             <a:r>
-              <a:rPr lang="en-GB" sz="3200" dirty="0"/>
-              <a:t>ETL Pipeline &amp; Airflow</a:t>
+              <a:rPr lang="en-GB" sz="3200" b="1" dirty="0"/>
+              <a:t>ETL Pipeline, Airflow &amp; Kafka</a:t>
             </a:r>
           </a:p>
           <a:p>
@@ -4459,8 +5488,8 @@
         </p:blipFill>
         <p:spPr>
           <a:xfrm>
-            <a:off x="586617" y="234622"/>
-            <a:ext cx="10268195" cy="2750820"/>
+            <a:off x="88490" y="148549"/>
+            <a:ext cx="11759382" cy="2750820"/>
           </a:xfrm>
           <a:prstGeom prst="rect">
             <a:avLst/>
@@ -4525,8 +5554,8 @@
         </p:blipFill>
         <p:spPr>
           <a:xfrm>
-            <a:off x="586618" y="3157589"/>
-            <a:ext cx="6315628" cy="3014611"/>
+            <a:off x="176981" y="3157589"/>
+            <a:ext cx="6725265" cy="3351366"/>
           </a:xfrm>
           <a:prstGeom prst="rect">
             <a:avLst/>
@@ -4593,12 +5622,144 @@
           <a:chExt cx="0" cy="0"/>
         </a:xfrm>
       </p:grpSpPr>
-      <p:sp>
-        <p:nvSpPr>
-          <p:cNvPr id="3" name="TextBox 2">
-            <a:extLst>
-              <a:ext uri="{FF2B5EF4-FFF2-40B4-BE49-F238E27FC236}">
-                <a16:creationId xmlns:a16="http://schemas.microsoft.com/office/drawing/2014/main" id="{28CC4748-A3E2-E458-ABFF-B841450C5EBD}"/>
+      <p:pic>
+        <p:nvPicPr>
+          <p:cNvPr id="7" name="Picture 6">
+            <a:extLst>
+              <a:ext uri="{FF2B5EF4-FFF2-40B4-BE49-F238E27FC236}">
+                <a16:creationId xmlns:a16="http://schemas.microsoft.com/office/drawing/2014/main" id="{A5DC1450-F404-7C1E-5C15-83BF7BCC33A7}"/>
+              </a:ext>
+            </a:extLst>
+          </p:cNvPr>
+          <p:cNvPicPr>
+            <a:picLocks noChangeAspect="1"/>
+          </p:cNvPicPr>
+          <p:nvPr/>
+        </p:nvPicPr>
+        <p:blipFill>
+          <a:blip r:embed="rId2">
+            <a:extLst>
+              <a:ext uri="{28A0092B-C50C-407E-A947-70E740481C1C}">
+                <a14:useLocalDpi xmlns:a14="http://schemas.microsoft.com/office/drawing/2010/main" val="0"/>
+              </a:ext>
+            </a:extLst>
+          </a:blip>
+          <a:stretch>
+            <a:fillRect/>
+          </a:stretch>
+        </p:blipFill>
+        <p:spPr>
+          <a:xfrm>
+            <a:off x="259080" y="3460649"/>
+            <a:ext cx="7406640" cy="1938798"/>
+          </a:xfrm>
+          <a:prstGeom prst="rect">
+            <a:avLst/>
+          </a:prstGeom>
+          <a:solidFill>
+            <a:srgbClr val="FFFFFF">
+              <a:shade val="85000"/>
+            </a:srgbClr>
+          </a:solidFill>
+          <a:ln w="88900" cap="sq">
+            <a:solidFill>
+              <a:srgbClr val="FFFFFF"/>
+            </a:solidFill>
+            <a:miter lim="800000"/>
+          </a:ln>
+          <a:effectLst>
+            <a:outerShdw blurRad="55000" dist="18000" dir="5400000" algn="tl" rotWithShape="0">
+              <a:srgbClr val="000000">
+                <a:alpha val="40000"/>
+              </a:srgbClr>
+            </a:outerShdw>
+          </a:effectLst>
+          <a:scene3d>
+            <a:camera prst="orthographicFront"/>
+            <a:lightRig rig="twoPt" dir="t">
+              <a:rot lat="0" lon="0" rev="7200000"/>
+            </a:lightRig>
+          </a:scene3d>
+          <a:sp3d>
+            <a:bevelT w="25400" h="19050"/>
+            <a:contourClr>
+              <a:srgbClr val="FFFFFF"/>
+            </a:contourClr>
+          </a:sp3d>
+        </p:spPr>
+      </p:pic>
+      <p:pic>
+        <p:nvPicPr>
+          <p:cNvPr id="9" name="Picture 8">
+            <a:extLst>
+              <a:ext uri="{FF2B5EF4-FFF2-40B4-BE49-F238E27FC236}">
+                <a16:creationId xmlns:a16="http://schemas.microsoft.com/office/drawing/2014/main" id="{3961F9EA-CE0D-AE09-7B4D-87AE19A97A55}"/>
+              </a:ext>
+            </a:extLst>
+          </p:cNvPr>
+          <p:cNvPicPr>
+            <a:picLocks noChangeAspect="1"/>
+          </p:cNvPicPr>
+          <p:nvPr/>
+        </p:nvPicPr>
+        <p:blipFill>
+          <a:blip r:embed="rId3">
+            <a:extLst>
+              <a:ext uri="{28A0092B-C50C-407E-A947-70E740481C1C}">
+                <a14:useLocalDpi xmlns:a14="http://schemas.microsoft.com/office/drawing/2010/main" val="0"/>
+              </a:ext>
+            </a:extLst>
+          </a:blip>
+          <a:stretch>
+            <a:fillRect/>
+          </a:stretch>
+        </p:blipFill>
+        <p:spPr>
+          <a:xfrm>
+            <a:off x="259080" y="1270818"/>
+            <a:ext cx="7406640" cy="1659195"/>
+          </a:xfrm>
+          <a:prstGeom prst="rect">
+            <a:avLst/>
+          </a:prstGeom>
+          <a:solidFill>
+            <a:srgbClr val="FFFFFF">
+              <a:shade val="85000"/>
+            </a:srgbClr>
+          </a:solidFill>
+          <a:ln w="88900" cap="sq">
+            <a:solidFill>
+              <a:srgbClr val="FFFFFF"/>
+            </a:solidFill>
+            <a:miter lim="800000"/>
+          </a:ln>
+          <a:effectLst>
+            <a:outerShdw blurRad="55000" dist="18000" dir="5400000" algn="tl" rotWithShape="0">
+              <a:srgbClr val="000000">
+                <a:alpha val="40000"/>
+              </a:srgbClr>
+            </a:outerShdw>
+          </a:effectLst>
+          <a:scene3d>
+            <a:camera prst="orthographicFront"/>
+            <a:lightRig rig="twoPt" dir="t">
+              <a:rot lat="0" lon="0" rev="7200000"/>
+            </a:lightRig>
+          </a:scene3d>
+          <a:sp3d>
+            <a:bevelT w="25400" h="19050"/>
+            <a:contourClr>
+              <a:srgbClr val="FFFFFF"/>
+            </a:contourClr>
+          </a:sp3d>
+        </p:spPr>
+      </p:pic>
+      <p:sp>
+        <p:nvSpPr>
+          <p:cNvPr id="11" name="TextBox 10">
+            <a:extLst>
+              <a:ext uri="{FF2B5EF4-FFF2-40B4-BE49-F238E27FC236}">
+                <a16:creationId xmlns:a16="http://schemas.microsoft.com/office/drawing/2014/main" id="{3FAEAC01-AAB0-F2E1-8A4A-43F7E109C019}"/>
               </a:ext>
             </a:extLst>
           </p:cNvPr>
@@ -4607,8 +5768,8 @@
         </p:nvSpPr>
         <p:spPr>
           <a:xfrm>
-            <a:off x="7914968" y="1807043"/>
-            <a:ext cx="6096000" cy="2893100"/>
+            <a:off x="7764043" y="2635046"/>
+            <a:ext cx="6096000" cy="1323439"/>
           </a:xfrm>
           <a:prstGeom prst="rect">
             <a:avLst/>
@@ -4622,14 +5783,104 @@
           <a:lstStyle/>
           <a:p>
             <a:r>
-              <a:rPr lang="en-GB" sz="3200" dirty="0"/>
+              <a:rPr lang="en-US" sz="2000" dirty="0"/>
+              <a:t>• Apache Kafka Producer-Consumer</a:t>
+            </a:r>
+          </a:p>
+          <a:p>
+            <a:r>
+              <a:rPr lang="en-US" sz="2000" dirty="0"/>
+              <a:t>   implementation</a:t>
+            </a:r>
+          </a:p>
+          <a:p>
+            <a:r>
+              <a:rPr lang="en-US" sz="2000" dirty="0"/>
+              <a:t>• Real-time healthcare message </a:t>
+            </a:r>
+          </a:p>
+          <a:p>
+            <a:r>
+              <a:rPr lang="en-US" sz="2000" dirty="0"/>
+              <a:t>   streaming demonstration</a:t>
+            </a:r>
+            <a:endParaRPr lang="en-GB" sz="2000" dirty="0"/>
+          </a:p>
+        </p:txBody>
+      </p:sp>
+    </p:spTree>
+    <p:extLst>
+      <p:ext uri="{BB962C8B-B14F-4D97-AF65-F5344CB8AC3E}">
+        <p14:creationId xmlns:p14="http://schemas.microsoft.com/office/powerpoint/2010/main" val="23292971"/>
+      </p:ext>
+    </p:extLst>
+  </p:cSld>
+  <p:clrMapOvr>
+    <a:masterClrMapping/>
+  </p:clrMapOvr>
+</p:sld>
+</file>
+
+<file path=ppt/slides/slide7.xml><?xml version="1.0" encoding="utf-8"?>
+<p:sld xmlns:a="http://schemas.openxmlformats.org/drawingml/2006/main" xmlns:r="http://schemas.openxmlformats.org/officeDocument/2006/relationships" xmlns:p="http://schemas.openxmlformats.org/presentationml/2006/main">
+  <p:cSld>
+    <p:spTree>
+      <p:nvGrpSpPr>
+        <p:cNvPr id="1" name=""/>
+        <p:cNvGrpSpPr/>
+        <p:nvPr/>
+      </p:nvGrpSpPr>
+      <p:grpSpPr>
+        <a:xfrm>
+          <a:off x="0" y="0"/>
+          <a:ext cx="0" cy="0"/>
+          <a:chOff x="0" y="0"/>
+          <a:chExt cx="0" cy="0"/>
+        </a:xfrm>
+      </p:grpSpPr>
+      <p:sp>
+        <p:nvSpPr>
+          <p:cNvPr id="3" name="TextBox 2">
+            <a:extLst>
+              <a:ext uri="{FF2B5EF4-FFF2-40B4-BE49-F238E27FC236}">
+                <a16:creationId xmlns:a16="http://schemas.microsoft.com/office/drawing/2014/main" id="{28CC4748-A3E2-E458-ABFF-B841450C5EBD}"/>
+              </a:ext>
+            </a:extLst>
+          </p:cNvPr>
+          <p:cNvSpPr txBox="1"/>
+          <p:nvPr/>
+        </p:nvSpPr>
+        <p:spPr>
+          <a:xfrm>
+            <a:off x="8268929" y="1049959"/>
+            <a:ext cx="3657601" cy="4924425"/>
+          </a:xfrm>
+          <a:prstGeom prst="rect">
+            <a:avLst/>
+          </a:prstGeom>
+          <a:noFill/>
+        </p:spPr>
+        <p:txBody>
+          <a:bodyPr wrap="square">
+            <a:spAutoFit/>
+          </a:bodyPr>
+          <a:lstStyle/>
+          <a:p>
+            <a:r>
+              <a:rPr lang="en-GB" sz="3200" b="1" dirty="0"/>
               <a:t>Big Data Processing </a:t>
             </a:r>
           </a:p>
           <a:p>
             <a:r>
-              <a:rPr lang="en-GB" sz="3200" dirty="0"/>
-              <a:t>using PySpark</a:t>
+              <a:rPr lang="en-GB" sz="3200" b="1" dirty="0"/>
+              <a:t>using PySpark &amp;</a:t>
+            </a:r>
+          </a:p>
+          <a:p>
+            <a:r>
+              <a:rPr lang="en-GB" sz="3200" b="1" dirty="0"/>
+              <a:t>Databricks</a:t>
             </a:r>
           </a:p>
           <a:p>
@@ -4638,7 +5889,7 @@
           <a:p>
             <a:r>
               <a:rPr lang="en-GB" sz="2000" dirty="0"/>
-              <a:t>• Processed 5000 healthcare records.</a:t>
+              <a:t>• Processed 5000 healthcare      records.</a:t>
             </a:r>
           </a:p>
           <a:p>
@@ -4664,6 +5915,13 @@
               <a:rPr lang="en-GB" sz="2000" dirty="0"/>
               <a:t>• Enabled scalable big data processing.</a:t>
             </a:r>
+          </a:p>
+          <a:p>
+            <a:r>
+              <a:rPr lang="en-US" sz="2000" dirty="0"/>
+              <a:t>• PySpark workflows validated using Databricks notebooks</a:t>
+            </a:r>
+            <a:endParaRPr lang="en-GB" sz="2000" dirty="0"/>
           </a:p>
         </p:txBody>
       </p:sp>
@@ -4746,7 +6004,7 @@
 </p:sld>
 </file>
 
-<file path=ppt/slides/slide7.xml><?xml version="1.0" encoding="utf-8"?>
+<file path=ppt/slides/slide8.xml><?xml version="1.0" encoding="utf-8"?>
 <p:sld xmlns:a="http://schemas.openxmlformats.org/drawingml/2006/main" xmlns:r="http://schemas.openxmlformats.org/officeDocument/2006/relationships" xmlns:p="http://schemas.openxmlformats.org/presentationml/2006/main">
   <p:cSld>
     <p:spTree>
@@ -4768,6 +6026,107 @@
           <p:cNvPr id="3" name="TextBox 2">
             <a:extLst>
               <a:ext uri="{FF2B5EF4-FFF2-40B4-BE49-F238E27FC236}">
+                <a16:creationId xmlns:a16="http://schemas.microsoft.com/office/drawing/2014/main" id="{4775C524-ED56-081A-F58A-CB89C889FD09}"/>
+              </a:ext>
+            </a:extLst>
+          </p:cNvPr>
+          <p:cNvSpPr txBox="1"/>
+          <p:nvPr/>
+        </p:nvSpPr>
+        <p:spPr>
+          <a:xfrm>
+            <a:off x="3146322" y="6336270"/>
+            <a:ext cx="6096000" cy="369332"/>
+          </a:xfrm>
+          <a:prstGeom prst="rect">
+            <a:avLst/>
+          </a:prstGeom>
+          <a:noFill/>
+        </p:spPr>
+        <p:txBody>
+          <a:bodyPr wrap="square">
+            <a:spAutoFit/>
+          </a:bodyPr>
+          <a:lstStyle/>
+          <a:p>
+            <a:r>
+              <a:rPr lang="en-GB" b="1" dirty="0"/>
+              <a:t>Figure: Databricks Notebook Executing PySpark Processing</a:t>
+            </a:r>
+          </a:p>
+        </p:txBody>
+      </p:sp>
+      <p:pic>
+        <p:nvPicPr>
+          <p:cNvPr id="5" name="Picture 4">
+            <a:extLst>
+              <a:ext uri="{FF2B5EF4-FFF2-40B4-BE49-F238E27FC236}">
+                <a16:creationId xmlns:a16="http://schemas.microsoft.com/office/drawing/2014/main" id="{7F0C07F3-4B1C-2857-FD95-4B3C0DAF06B8}"/>
+              </a:ext>
+            </a:extLst>
+          </p:cNvPr>
+          <p:cNvPicPr>
+            <a:picLocks noChangeAspect="1"/>
+          </p:cNvPicPr>
+          <p:nvPr/>
+        </p:nvPicPr>
+        <p:blipFill>
+          <a:blip r:embed="rId2">
+            <a:extLst>
+              <a:ext uri="{28A0092B-C50C-407E-A947-70E740481C1C}">
+                <a14:useLocalDpi xmlns:a14="http://schemas.microsoft.com/office/drawing/2010/main" val="0"/>
+              </a:ext>
+            </a:extLst>
+          </a:blip>
+          <a:stretch>
+            <a:fillRect/>
+          </a:stretch>
+        </p:blipFill>
+        <p:spPr>
+          <a:xfrm>
+            <a:off x="412954" y="115217"/>
+            <a:ext cx="11051458" cy="6086460"/>
+          </a:xfrm>
+          <a:prstGeom prst="rect">
+            <a:avLst/>
+          </a:prstGeom>
+        </p:spPr>
+      </p:pic>
+    </p:spTree>
+    <p:extLst>
+      <p:ext uri="{BB962C8B-B14F-4D97-AF65-F5344CB8AC3E}">
+        <p14:creationId xmlns:p14="http://schemas.microsoft.com/office/powerpoint/2010/main" val="3776562988"/>
+      </p:ext>
+    </p:extLst>
+  </p:cSld>
+  <p:clrMapOvr>
+    <a:masterClrMapping/>
+  </p:clrMapOvr>
+</p:sld>
+</file>
+
+<file path=ppt/slides/slide9.xml><?xml version="1.0" encoding="utf-8"?>
+<p:sld xmlns:a="http://schemas.openxmlformats.org/drawingml/2006/main" xmlns:r="http://schemas.openxmlformats.org/officeDocument/2006/relationships" xmlns:p="http://schemas.openxmlformats.org/presentationml/2006/main">
+  <p:cSld>
+    <p:spTree>
+      <p:nvGrpSpPr>
+        <p:cNvPr id="1" name=""/>
+        <p:cNvGrpSpPr/>
+        <p:nvPr/>
+      </p:nvGrpSpPr>
+      <p:grpSpPr>
+        <a:xfrm>
+          <a:off x="0" y="0"/>
+          <a:ext cx="0" cy="0"/>
+          <a:chOff x="0" y="0"/>
+          <a:chExt cx="0" cy="0"/>
+        </a:xfrm>
+      </p:grpSpPr>
+      <p:sp>
+        <p:nvSpPr>
+          <p:cNvPr id="3" name="TextBox 2">
+            <a:extLst>
+              <a:ext uri="{FF2B5EF4-FFF2-40B4-BE49-F238E27FC236}">
                 <a16:creationId xmlns:a16="http://schemas.microsoft.com/office/drawing/2014/main" id="{186C71BE-82D2-6080-76CD-F4BD40D7DFAB}"/>
               </a:ext>
             </a:extLst>
@@ -4792,13 +6151,13 @@
           <a:lstStyle/>
           <a:p>
             <a:r>
-              <a:rPr lang="en-GB" sz="3200" dirty="0"/>
+              <a:rPr lang="en-GB" sz="3200" b="1" dirty="0"/>
               <a:t>AWS RDS &amp; </a:t>
             </a:r>
           </a:p>
           <a:p>
             <a:r>
-              <a:rPr lang="en-GB" sz="3200" dirty="0"/>
+              <a:rPr lang="en-GB" sz="3200" b="1" dirty="0"/>
               <a:t>Data Warehouse</a:t>
             </a:r>
           </a:p>
@@ -4967,328 +6326,6 @@
     <p:extLst>
       <p:ext uri="{BB962C8B-B14F-4D97-AF65-F5344CB8AC3E}">
         <p14:creationId xmlns:p14="http://schemas.microsoft.com/office/powerpoint/2010/main" val="574445657"/>
-      </p:ext>
-    </p:extLst>
-  </p:cSld>
-  <p:clrMapOvr>
-    <a:masterClrMapping/>
-  </p:clrMapOvr>
-</p:sld>
-</file>
-
-<file path=ppt/slides/slide8.xml><?xml version="1.0" encoding="utf-8"?>
-<p:sld xmlns:a="http://schemas.openxmlformats.org/drawingml/2006/main" xmlns:r="http://schemas.openxmlformats.org/officeDocument/2006/relationships" xmlns:p="http://schemas.openxmlformats.org/presentationml/2006/main">
-  <p:cSld>
-    <p:spTree>
-      <p:nvGrpSpPr>
-        <p:cNvPr id="1" name=""/>
-        <p:cNvGrpSpPr/>
-        <p:nvPr/>
-      </p:nvGrpSpPr>
-      <p:grpSpPr>
-        <a:xfrm>
-          <a:off x="0" y="0"/>
-          <a:ext cx="0" cy="0"/>
-          <a:chOff x="0" y="0"/>
-          <a:chExt cx="0" cy="0"/>
-        </a:xfrm>
-      </p:grpSpPr>
-      <p:sp>
-        <p:nvSpPr>
-          <p:cNvPr id="3" name="TextBox 2">
-            <a:extLst>
-              <a:ext uri="{FF2B5EF4-FFF2-40B4-BE49-F238E27FC236}">
-                <a16:creationId xmlns:a16="http://schemas.microsoft.com/office/drawing/2014/main" id="{9E4477BC-B009-9F2D-792B-5ABADDF67C8C}"/>
-              </a:ext>
-            </a:extLst>
-          </p:cNvPr>
-          <p:cNvSpPr txBox="1"/>
-          <p:nvPr/>
-        </p:nvSpPr>
-        <p:spPr>
-          <a:xfrm>
-            <a:off x="7639665" y="2396131"/>
-            <a:ext cx="6096000" cy="2400657"/>
-          </a:xfrm>
-          <a:prstGeom prst="rect">
-            <a:avLst/>
-          </a:prstGeom>
-          <a:noFill/>
-        </p:spPr>
-        <p:txBody>
-          <a:bodyPr wrap="square">
-            <a:spAutoFit/>
-          </a:bodyPr>
-          <a:lstStyle/>
-          <a:p>
-            <a:r>
-              <a:rPr lang="en-GB" sz="3200" dirty="0"/>
-              <a:t>Exploratory Data Analysis</a:t>
-            </a:r>
-          </a:p>
-          <a:p>
-            <a:endParaRPr lang="en-GB" dirty="0"/>
-          </a:p>
-          <a:p>
-            <a:r>
-              <a:rPr lang="en-GB" sz="2000" dirty="0"/>
-              <a:t>• Disease distribution analysis.</a:t>
-            </a:r>
-          </a:p>
-          <a:p>
-            <a:r>
-              <a:rPr lang="en-GB" sz="2000" dirty="0"/>
-              <a:t>• Gender and city-wise analysis.</a:t>
-            </a:r>
-          </a:p>
-          <a:p>
-            <a:r>
-              <a:rPr lang="en-GB" sz="2000" dirty="0"/>
-              <a:t>• Admission status analysis.</a:t>
-            </a:r>
-          </a:p>
-          <a:p>
-            <a:r>
-              <a:rPr lang="en-GB" sz="2000" dirty="0"/>
-              <a:t>• Treatment cost statistics.</a:t>
-            </a:r>
-          </a:p>
-          <a:p>
-            <a:r>
-              <a:rPr lang="en-GB" sz="2000" dirty="0"/>
-              <a:t>• Generated healthcare insights.</a:t>
-            </a:r>
-          </a:p>
-        </p:txBody>
-      </p:sp>
-      <p:pic>
-        <p:nvPicPr>
-          <p:cNvPr id="5" name="Picture 4">
-            <a:extLst>
-              <a:ext uri="{FF2B5EF4-FFF2-40B4-BE49-F238E27FC236}">
-                <a16:creationId xmlns:a16="http://schemas.microsoft.com/office/drawing/2014/main" id="{AB95E666-E490-C7ED-937D-DC532D93691F}"/>
-              </a:ext>
-            </a:extLst>
-          </p:cNvPr>
-          <p:cNvPicPr>
-            <a:picLocks noChangeAspect="1"/>
-          </p:cNvPicPr>
-          <p:nvPr/>
-        </p:nvPicPr>
-        <p:blipFill>
-          <a:blip r:embed="rId2">
-            <a:extLst>
-              <a:ext uri="{28A0092B-C50C-407E-A947-70E740481C1C}">
-                <a14:useLocalDpi xmlns:a14="http://schemas.microsoft.com/office/drawing/2010/main" val="0"/>
-              </a:ext>
-            </a:extLst>
-          </a:blip>
-          <a:stretch>
-            <a:fillRect/>
-          </a:stretch>
-        </p:blipFill>
-        <p:spPr>
-          <a:xfrm>
-            <a:off x="168130" y="247650"/>
-            <a:ext cx="7373211" cy="6362700"/>
-          </a:xfrm>
-          <a:prstGeom prst="rect">
-            <a:avLst/>
-          </a:prstGeom>
-          <a:solidFill>
-            <a:srgbClr val="FFFFFF">
-              <a:shade val="85000"/>
-            </a:srgbClr>
-          </a:solidFill>
-          <a:ln w="88900" cap="sq">
-            <a:solidFill>
-              <a:srgbClr val="FFFFFF"/>
-            </a:solidFill>
-            <a:miter lim="800000"/>
-          </a:ln>
-          <a:effectLst>
-            <a:outerShdw blurRad="55000" dist="18000" dir="5400000" algn="tl" rotWithShape="0">
-              <a:srgbClr val="000000">
-                <a:alpha val="40000"/>
-              </a:srgbClr>
-            </a:outerShdw>
-          </a:effectLst>
-          <a:scene3d>
-            <a:camera prst="orthographicFront"/>
-            <a:lightRig rig="twoPt" dir="t">
-              <a:rot lat="0" lon="0" rev="7200000"/>
-            </a:lightRig>
-          </a:scene3d>
-          <a:sp3d>
-            <a:bevelT w="25400" h="19050"/>
-            <a:contourClr>
-              <a:srgbClr val="FFFFFF"/>
-            </a:contourClr>
-          </a:sp3d>
-        </p:spPr>
-      </p:pic>
-    </p:spTree>
-    <p:extLst>
-      <p:ext uri="{BB962C8B-B14F-4D97-AF65-F5344CB8AC3E}">
-        <p14:creationId xmlns:p14="http://schemas.microsoft.com/office/powerpoint/2010/main" val="1555976044"/>
-      </p:ext>
-    </p:extLst>
-  </p:cSld>
-  <p:clrMapOvr>
-    <a:masterClrMapping/>
-  </p:clrMapOvr>
-</p:sld>
-</file>
-
-<file path=ppt/slides/slide9.xml><?xml version="1.0" encoding="utf-8"?>
-<p:sld xmlns:a="http://schemas.openxmlformats.org/drawingml/2006/main" xmlns:r="http://schemas.openxmlformats.org/officeDocument/2006/relationships" xmlns:p="http://schemas.openxmlformats.org/presentationml/2006/main">
-  <p:cSld>
-    <p:spTree>
-      <p:nvGrpSpPr>
-        <p:cNvPr id="1" name=""/>
-        <p:cNvGrpSpPr/>
-        <p:nvPr/>
-      </p:nvGrpSpPr>
-      <p:grpSpPr>
-        <a:xfrm>
-          <a:off x="0" y="0"/>
-          <a:ext cx="0" cy="0"/>
-          <a:chOff x="0" y="0"/>
-          <a:chExt cx="0" cy="0"/>
-        </a:xfrm>
-      </p:grpSpPr>
-      <p:sp>
-        <p:nvSpPr>
-          <p:cNvPr id="3" name="TextBox 2">
-            <a:extLst>
-              <a:ext uri="{FF2B5EF4-FFF2-40B4-BE49-F238E27FC236}">
-                <a16:creationId xmlns:a16="http://schemas.microsoft.com/office/drawing/2014/main" id="{4BB448C2-9C61-238F-4940-6D285C14ED9C}"/>
-              </a:ext>
-            </a:extLst>
-          </p:cNvPr>
-          <p:cNvSpPr txBox="1"/>
-          <p:nvPr/>
-        </p:nvSpPr>
-        <p:spPr>
-          <a:xfrm>
-            <a:off x="117987" y="3861984"/>
-            <a:ext cx="11541474" cy="2092881"/>
-          </a:xfrm>
-          <a:prstGeom prst="rect">
-            <a:avLst/>
-          </a:prstGeom>
-          <a:noFill/>
-        </p:spPr>
-        <p:txBody>
-          <a:bodyPr wrap="square">
-            <a:spAutoFit/>
-          </a:bodyPr>
-          <a:lstStyle/>
-          <a:p>
-            <a:r>
-              <a:rPr lang="en-GB" sz="3200" dirty="0"/>
-              <a:t>Machine Learning Model</a:t>
-            </a:r>
-          </a:p>
-          <a:p>
-            <a:endParaRPr lang="en-GB" dirty="0"/>
-          </a:p>
-          <a:p>
-            <a:r>
-              <a:rPr lang="en-GB" sz="2000" dirty="0"/>
-              <a:t>• Random Forest Regressor implemented.</a:t>
-            </a:r>
-          </a:p>
-          <a:p>
-            <a:r>
-              <a:rPr lang="en-GB" sz="2000" dirty="0"/>
-              <a:t>• Treatment cost prediction performed.</a:t>
-            </a:r>
-          </a:p>
-          <a:p>
-            <a:r>
-              <a:rPr lang="en-GB" sz="2000" dirty="0"/>
-              <a:t>• Model trained on healthcare dataset.</a:t>
-            </a:r>
-          </a:p>
-          <a:p>
-            <a:r>
-              <a:rPr lang="en-GB" sz="2000" dirty="0"/>
-              <a:t>• Performance evaluated using MAE.</a:t>
-            </a:r>
-          </a:p>
-        </p:txBody>
-      </p:sp>
-      <p:pic>
-        <p:nvPicPr>
-          <p:cNvPr id="5" name="Picture 4">
-            <a:extLst>
-              <a:ext uri="{FF2B5EF4-FFF2-40B4-BE49-F238E27FC236}">
-                <a16:creationId xmlns:a16="http://schemas.microsoft.com/office/drawing/2014/main" id="{A5D5C314-CBCF-CD42-FD1D-5ED2C119DB95}"/>
-              </a:ext>
-            </a:extLst>
-          </p:cNvPr>
-          <p:cNvPicPr>
-            <a:picLocks noChangeAspect="1"/>
-          </p:cNvPicPr>
-          <p:nvPr/>
-        </p:nvPicPr>
-        <p:blipFill>
-          <a:blip r:embed="rId2">
-            <a:extLst>
-              <a:ext uri="{28A0092B-C50C-407E-A947-70E740481C1C}">
-                <a14:useLocalDpi xmlns:a14="http://schemas.microsoft.com/office/drawing/2010/main" val="0"/>
-              </a:ext>
-            </a:extLst>
-          </a:blip>
-          <a:stretch>
-            <a:fillRect/>
-          </a:stretch>
-        </p:blipFill>
-        <p:spPr>
-          <a:xfrm>
-            <a:off x="286733" y="286035"/>
-            <a:ext cx="11472648" cy="3314700"/>
-          </a:xfrm>
-          <a:prstGeom prst="rect">
-            <a:avLst/>
-          </a:prstGeom>
-          <a:solidFill>
-            <a:srgbClr val="FFFFFF">
-              <a:shade val="85000"/>
-            </a:srgbClr>
-          </a:solidFill>
-          <a:ln w="88900" cap="sq">
-            <a:solidFill>
-              <a:srgbClr val="FFFFFF"/>
-            </a:solidFill>
-            <a:miter lim="800000"/>
-          </a:ln>
-          <a:effectLst>
-            <a:outerShdw blurRad="55000" dist="18000" dir="5400000" algn="tl" rotWithShape="0">
-              <a:srgbClr val="000000">
-                <a:alpha val="40000"/>
-              </a:srgbClr>
-            </a:outerShdw>
-          </a:effectLst>
-          <a:scene3d>
-            <a:camera prst="orthographicFront"/>
-            <a:lightRig rig="twoPt" dir="t">
-              <a:rot lat="0" lon="0" rev="7200000"/>
-            </a:lightRig>
-          </a:scene3d>
-          <a:sp3d>
-            <a:bevelT w="25400" h="19050"/>
-            <a:contourClr>
-              <a:srgbClr val="FFFFFF"/>
-            </a:contourClr>
-          </a:sp3d>
-        </p:spPr>
-      </p:pic>
-    </p:spTree>
-    <p:extLst>
-      <p:ext uri="{BB962C8B-B14F-4D97-AF65-F5344CB8AC3E}">
-        <p14:creationId xmlns:p14="http://schemas.microsoft.com/office/powerpoint/2010/main" val="2032054767"/>
       </p:ext>
     </p:extLst>
   </p:cSld>
@@ -5591,4 +6628,299 @@
     </a:ext>
   </a:extLst>
 </a:theme>
+</file>
+
+<file path=ppt/theme/theme2.xml><?xml version="1.0" encoding="utf-8"?>
+<a:theme xmlns:a="http://schemas.openxmlformats.org/drawingml/2006/main" name="Office Theme">
+  <a:themeElements>
+    <a:clrScheme name="Office">
+      <a:dk1>
+        <a:sysClr val="windowText" lastClr="000000"/>
+      </a:dk1>
+      <a:lt1>
+        <a:sysClr val="window" lastClr="FFFFFF"/>
+      </a:lt1>
+      <a:dk2>
+        <a:srgbClr val="44546A"/>
+      </a:dk2>
+      <a:lt2>
+        <a:srgbClr val="E7E6E6"/>
+      </a:lt2>
+      <a:accent1>
+        <a:srgbClr val="4472C4"/>
+      </a:accent1>
+      <a:accent2>
+        <a:srgbClr val="ED7D31"/>
+      </a:accent2>
+      <a:accent3>
+        <a:srgbClr val="A5A5A5"/>
+      </a:accent3>
+      <a:accent4>
+        <a:srgbClr val="FFC000"/>
+      </a:accent4>
+      <a:accent5>
+        <a:srgbClr val="5B9BD5"/>
+      </a:accent5>
+      <a:accent6>
+        <a:srgbClr val="70AD47"/>
+      </a:accent6>
+      <a:hlink>
+        <a:srgbClr val="0563C1"/>
+      </a:hlink>
+      <a:folHlink>
+        <a:srgbClr val="954F72"/>
+      </a:folHlink>
+    </a:clrScheme>
+    <a:fontScheme name="Office">
+      <a:majorFont>
+        <a:latin typeface="Calibri Light" panose="020F0302020204030204"/>
+        <a:ea typeface=""/>
+        <a:cs typeface=""/>
+        <a:font script="Jpan" typeface="游ゴシック Light"/>
+        <a:font script="Hang" typeface="맑은 고딕"/>
+        <a:font script="Hans" typeface="等线 Light"/>
+        <a:font script="Hant" typeface="新細明體"/>
+        <a:font script="Arab" typeface="Times New Roman"/>
+        <a:font script="Hebr" typeface="Times New Roman"/>
+        <a:font script="Thai" typeface="Angsana New"/>
+        <a:font script="Ethi" typeface="Nyala"/>
+        <a:font script="Beng" typeface="Vrinda"/>
+        <a:font script="Gujr" typeface="Shruti"/>
+        <a:font script="Khmr" typeface="MoolBoran"/>
+        <a:font script="Knda" typeface="Tunga"/>
+        <a:font script="Guru" typeface="Raavi"/>
+        <a:font script="Cans" typeface="Euphemia"/>
+        <a:font script="Cher" typeface="Plantagenet Cherokee"/>
+        <a:font script="Yiii" typeface="Microsoft Yi Baiti"/>
+        <a:font script="Tibt" typeface="Microsoft Himalaya"/>
+        <a:font script="Thaa" typeface="MV Boli"/>
+        <a:font script="Deva" typeface="Mangal"/>
+        <a:font script="Telu" typeface="Gautami"/>
+        <a:font script="Taml" typeface="Latha"/>
+        <a:font script="Syrc" typeface="Estrangelo Edessa"/>
+        <a:font script="Orya" typeface="Kalinga"/>
+        <a:font script="Mlym" typeface="Kartika"/>
+        <a:font script="Laoo" typeface="DokChampa"/>
+        <a:font script="Sinh" typeface="Iskoola Pota"/>
+        <a:font script="Mong" typeface="Mongolian Baiti"/>
+        <a:font script="Viet" typeface="Times New Roman"/>
+        <a:font script="Uigh" typeface="Microsoft Uighur"/>
+        <a:font script="Geor" typeface="Sylfaen"/>
+        <a:font script="Armn" typeface="Arial"/>
+        <a:font script="Bugi" typeface="Leelawadee UI"/>
+        <a:font script="Bopo" typeface="Microsoft JhengHei"/>
+        <a:font script="Java" typeface="Javanese Text"/>
+        <a:font script="Lisu" typeface="Segoe UI"/>
+        <a:font script="Mymr" typeface="Myanmar Text"/>
+        <a:font script="Nkoo" typeface="Ebrima"/>
+        <a:font script="Olck" typeface="Nirmala UI"/>
+        <a:font script="Osma" typeface="Ebrima"/>
+        <a:font script="Phag" typeface="Phagspa"/>
+        <a:font script="Syrn" typeface="Estrangelo Edessa"/>
+        <a:font script="Syrj" typeface="Estrangelo Edessa"/>
+        <a:font script="Syre" typeface="Estrangelo Edessa"/>
+        <a:font script="Sora" typeface="Nirmala UI"/>
+        <a:font script="Tale" typeface="Microsoft Tai Le"/>
+        <a:font script="Talu" typeface="Microsoft New Tai Lue"/>
+        <a:font script="Tfng" typeface="Ebrima"/>
+      </a:majorFont>
+      <a:minorFont>
+        <a:latin typeface="Calibri" panose="020F0502020204030204"/>
+        <a:ea typeface=""/>
+        <a:cs typeface=""/>
+        <a:font script="Jpan" typeface="游ゴシック"/>
+        <a:font script="Hang" typeface="맑은 고딕"/>
+        <a:font script="Hans" typeface="等线"/>
+        <a:font script="Hant" typeface="新細明體"/>
+        <a:font script="Arab" typeface="Arial"/>
+        <a:font script="Hebr" typeface="Arial"/>
+        <a:font script="Thai" typeface="Cordia New"/>
+        <a:font script="Ethi" typeface="Nyala"/>
+        <a:font script="Beng" typeface="Vrinda"/>
+        <a:font script="Gujr" typeface="Shruti"/>
+        <a:font script="Khmr" typeface="DaunPenh"/>
+        <a:font script="Knda" typeface="Tunga"/>
+        <a:font script="Guru" typeface="Raavi"/>
+        <a:font script="Cans" typeface="Euphemia"/>
+        <a:font script="Cher" typeface="Plantagenet Cherokee"/>
+        <a:font script="Yiii" typeface="Microsoft Yi Baiti"/>
+        <a:font script="Tibt" typeface="Microsoft Himalaya"/>
+        <a:font script="Thaa" typeface="MV Boli"/>
+        <a:font script="Deva" typeface="Mangal"/>
+        <a:font script="Telu" typeface="Gautami"/>
+        <a:font script="Taml" typeface="Latha"/>
+        <a:font script="Syrc" typeface="Estrangelo Edessa"/>
+        <a:font script="Orya" typeface="Kalinga"/>
+        <a:font script="Mlym" typeface="Kartika"/>
+        <a:font script="Laoo" typeface="DokChampa"/>
+        <a:font script="Sinh" typeface="Iskoola Pota"/>
+        <a:font script="Mong" typeface="Mongolian Baiti"/>
+        <a:font script="Viet" typeface="Arial"/>
+        <a:font script="Uigh" typeface="Microsoft Uighur"/>
+        <a:font script="Geor" typeface="Sylfaen"/>
+        <a:font script="Armn" typeface="Arial"/>
+        <a:font script="Bugi" typeface="Leelawadee UI"/>
+        <a:font script="Bopo" typeface="Microsoft JhengHei"/>
+        <a:font script="Java" typeface="Javanese Text"/>
+        <a:font script="Lisu" typeface="Segoe UI"/>
+        <a:font script="Mymr" typeface="Myanmar Text"/>
+        <a:font script="Nkoo" typeface="Ebrima"/>
+        <a:font script="Olck" typeface="Nirmala UI"/>
+        <a:font script="Osma" typeface="Ebrima"/>
+        <a:font script="Phag" typeface="Phagspa"/>
+        <a:font script="Syrn" typeface="Estrangelo Edessa"/>
+        <a:font script="Syrj" typeface="Estrangelo Edessa"/>
+        <a:font script="Syre" typeface="Estrangelo Edessa"/>
+        <a:font script="Sora" typeface="Nirmala UI"/>
+        <a:font script="Tale" typeface="Microsoft Tai Le"/>
+        <a:font script="Talu" typeface="Microsoft New Tai Lue"/>
+        <a:font script="Tfng" typeface="Ebrima"/>
+      </a:minorFont>
+    </a:fontScheme>
+    <a:fmtScheme name="Office">
+      <a:fillStyleLst>
+        <a:solidFill>
+          <a:schemeClr val="phClr"/>
+        </a:solidFill>
+        <a:gradFill rotWithShape="1">
+          <a:gsLst>
+            <a:gs pos="0">
+              <a:schemeClr val="phClr">
+                <a:lumMod val="110000"/>
+                <a:satMod val="105000"/>
+                <a:tint val="67000"/>
+              </a:schemeClr>
+            </a:gs>
+            <a:gs pos="50000">
+              <a:schemeClr val="phClr">
+                <a:lumMod val="105000"/>
+                <a:satMod val="103000"/>
+                <a:tint val="73000"/>
+              </a:schemeClr>
+            </a:gs>
+            <a:gs pos="100000">
+              <a:schemeClr val="phClr">
+                <a:lumMod val="105000"/>
+                <a:satMod val="109000"/>
+                <a:tint val="81000"/>
+              </a:schemeClr>
+            </a:gs>
+          </a:gsLst>
+          <a:lin ang="5400000" scaled="0"/>
+        </a:gradFill>
+        <a:gradFill rotWithShape="1">
+          <a:gsLst>
+            <a:gs pos="0">
+              <a:schemeClr val="phClr">
+                <a:satMod val="103000"/>
+                <a:lumMod val="102000"/>
+                <a:tint val="94000"/>
+              </a:schemeClr>
+            </a:gs>
+            <a:gs pos="50000">
+              <a:schemeClr val="phClr">
+                <a:satMod val="110000"/>
+                <a:lumMod val="100000"/>
+                <a:shade val="100000"/>
+              </a:schemeClr>
+            </a:gs>
+            <a:gs pos="100000">
+              <a:schemeClr val="phClr">
+                <a:lumMod val="99000"/>
+                <a:satMod val="120000"/>
+                <a:shade val="78000"/>
+              </a:schemeClr>
+            </a:gs>
+          </a:gsLst>
+          <a:lin ang="5400000" scaled="0"/>
+        </a:gradFill>
+      </a:fillStyleLst>
+      <a:lnStyleLst>
+        <a:ln w="6350" cap="flat" cmpd="sng" algn="ctr">
+          <a:solidFill>
+            <a:schemeClr val="phClr"/>
+          </a:solidFill>
+          <a:prstDash val="solid"/>
+          <a:miter lim="800000"/>
+        </a:ln>
+        <a:ln w="12700" cap="flat" cmpd="sng" algn="ctr">
+          <a:solidFill>
+            <a:schemeClr val="phClr"/>
+          </a:solidFill>
+          <a:prstDash val="solid"/>
+          <a:miter lim="800000"/>
+        </a:ln>
+        <a:ln w="19050" cap="flat" cmpd="sng" algn="ctr">
+          <a:solidFill>
+            <a:schemeClr val="phClr"/>
+          </a:solidFill>
+          <a:prstDash val="solid"/>
+          <a:miter lim="800000"/>
+        </a:ln>
+      </a:lnStyleLst>
+      <a:effectStyleLst>
+        <a:effectStyle>
+          <a:effectLst/>
+        </a:effectStyle>
+        <a:effectStyle>
+          <a:effectLst/>
+        </a:effectStyle>
+        <a:effectStyle>
+          <a:effectLst>
+            <a:outerShdw blurRad="57150" dist="19050" dir="5400000" algn="ctr" rotWithShape="0">
+              <a:srgbClr val="000000">
+                <a:alpha val="63000"/>
+              </a:srgbClr>
+            </a:outerShdw>
+          </a:effectLst>
+        </a:effectStyle>
+      </a:effectStyleLst>
+      <a:bgFillStyleLst>
+        <a:solidFill>
+          <a:schemeClr val="phClr"/>
+        </a:solidFill>
+        <a:solidFill>
+          <a:schemeClr val="phClr">
+            <a:tint val="95000"/>
+            <a:satMod val="170000"/>
+          </a:schemeClr>
+        </a:solidFill>
+        <a:gradFill rotWithShape="1">
+          <a:gsLst>
+            <a:gs pos="0">
+              <a:schemeClr val="phClr">
+                <a:tint val="93000"/>
+                <a:satMod val="150000"/>
+                <a:shade val="98000"/>
+                <a:lumMod val="102000"/>
+              </a:schemeClr>
+            </a:gs>
+            <a:gs pos="50000">
+              <a:schemeClr val="phClr">
+                <a:tint val="98000"/>
+                <a:satMod val="130000"/>
+                <a:shade val="90000"/>
+                <a:lumMod val="103000"/>
+              </a:schemeClr>
+            </a:gs>
+            <a:gs pos="100000">
+              <a:schemeClr val="phClr">
+                <a:shade val="63000"/>
+                <a:satMod val="120000"/>
+              </a:schemeClr>
+            </a:gs>
+          </a:gsLst>
+          <a:lin ang="5400000" scaled="0"/>
+        </a:gradFill>
+      </a:bgFillStyleLst>
+    </a:fmtScheme>
+  </a:themeElements>
+  <a:objectDefaults/>
+  <a:extraClrSchemeLst/>
+  <a:extLst>
+    <a:ext uri="{05A4C25C-085E-4340-85A3-A5531E510DB2}">
+      <thm15:themeFamily xmlns:thm15="http://schemas.microsoft.com/office/thememl/2012/main" name="Office Theme" id="{62F939B6-93AF-4DB8-9C6B-D6C7DFDC589F}" vid="{4A3C46E8-61CC-4603-A589-7422A47A8E4A}"/>
+    </a:ext>
+  </a:extLst>
+</a:theme>
 </file>
</xml_diff>

<commit_message>
Finalize IITJ Capstone Project presentation
Finalized the Healthcare Analytics Pipeline Capstone Project for IIT Jodhpur PGDDE submission.

Updates include:
- Final project presentation (PPT) revisions and formatting improvements
- Updated cover slide with group details and project subtitle
- Refined project architecture, key results, conclusion, and future scope sections
- Added final project resources and submission links
- Completed documentation and repository updates for final submission

Project: Healthcare Analytics Pipeline for MediCare Hospital
An End-to-End Scalable Data Engineering & Analytics Platform
</commit_message>
<xml_diff>
--- a/PGDDE_Capstone_Healthcare_Analytics_Pipeline_IITJ.pptx
+++ b/PGDDE_Capstone_Healthcare_Analytics_Pipeline_IITJ.pptx
@@ -5,7 +5,7 @@
     <p:sldMasterId id="2147483648" r:id="rId1"/>
   </p:sldMasterIdLst>
   <p:notesMasterIdLst>
-    <p:notesMasterId r:id="rId16"/>
+    <p:notesMasterId r:id="rId17"/>
   </p:notesMasterIdLst>
   <p:sldIdLst>
     <p:sldId id="256" r:id="rId2"/>
@@ -21,7 +21,8 @@
     <p:sldId id="264" r:id="rId12"/>
     <p:sldId id="269" r:id="rId13"/>
     <p:sldId id="265" r:id="rId14"/>
-    <p:sldId id="266" r:id="rId15"/>
+    <p:sldId id="270" r:id="rId15"/>
+    <p:sldId id="271" r:id="rId16"/>
   </p:sldIdLst>
   <p:sldSz cx="12192000" cy="6858000"/>
   <p:notesSz cx="6858000" cy="9144000"/>
@@ -210,7 +211,7 @@
           <a:p>
             <a:fld id="{6CAD6177-CAEF-4E70-8DEE-78C553712586}" type="datetimeFigureOut">
               <a:rPr lang="en-GB" smtClean="0"/>
-              <a:t>31/05/2026</a:t>
+              <a:t>03/07/2026</a:t>
             </a:fld>
             <a:endParaRPr lang="en-GB"/>
           </a:p>
@@ -711,7 +712,7 @@
           <a:p>
             <a:fld id="{8727B1B5-114F-462F-9F43-A96471EB3E77}" type="datetimeFigureOut">
               <a:rPr lang="en-GB" smtClean="0"/>
-              <a:t>31/05/2026</a:t>
+              <a:t>03/07/2026</a:t>
             </a:fld>
             <a:endParaRPr lang="en-GB"/>
           </a:p>
@@ -911,7 +912,7 @@
           <a:p>
             <a:fld id="{8727B1B5-114F-462F-9F43-A96471EB3E77}" type="datetimeFigureOut">
               <a:rPr lang="en-GB" smtClean="0"/>
-              <a:t>31/05/2026</a:t>
+              <a:t>03/07/2026</a:t>
             </a:fld>
             <a:endParaRPr lang="en-GB"/>
           </a:p>
@@ -1121,7 +1122,7 @@
           <a:p>
             <a:fld id="{8727B1B5-114F-462F-9F43-A96471EB3E77}" type="datetimeFigureOut">
               <a:rPr lang="en-GB" smtClean="0"/>
-              <a:t>31/05/2026</a:t>
+              <a:t>03/07/2026</a:t>
             </a:fld>
             <a:endParaRPr lang="en-GB"/>
           </a:p>
@@ -1321,7 +1322,7 @@
           <a:p>
             <a:fld id="{8727B1B5-114F-462F-9F43-A96471EB3E77}" type="datetimeFigureOut">
               <a:rPr lang="en-GB" smtClean="0"/>
-              <a:t>31/05/2026</a:t>
+              <a:t>03/07/2026</a:t>
             </a:fld>
             <a:endParaRPr lang="en-GB"/>
           </a:p>
@@ -1597,7 +1598,7 @@
           <a:p>
             <a:fld id="{8727B1B5-114F-462F-9F43-A96471EB3E77}" type="datetimeFigureOut">
               <a:rPr lang="en-GB" smtClean="0"/>
-              <a:t>31/05/2026</a:t>
+              <a:t>03/07/2026</a:t>
             </a:fld>
             <a:endParaRPr lang="en-GB"/>
           </a:p>
@@ -1865,7 +1866,7 @@
           <a:p>
             <a:fld id="{8727B1B5-114F-462F-9F43-A96471EB3E77}" type="datetimeFigureOut">
               <a:rPr lang="en-GB" smtClean="0"/>
-              <a:t>31/05/2026</a:t>
+              <a:t>03/07/2026</a:t>
             </a:fld>
             <a:endParaRPr lang="en-GB"/>
           </a:p>
@@ -2280,7 +2281,7 @@
           <a:p>
             <a:fld id="{8727B1B5-114F-462F-9F43-A96471EB3E77}" type="datetimeFigureOut">
               <a:rPr lang="en-GB" smtClean="0"/>
-              <a:t>31/05/2026</a:t>
+              <a:t>03/07/2026</a:t>
             </a:fld>
             <a:endParaRPr lang="en-GB"/>
           </a:p>
@@ -2422,7 +2423,7 @@
           <a:p>
             <a:fld id="{8727B1B5-114F-462F-9F43-A96471EB3E77}" type="datetimeFigureOut">
               <a:rPr lang="en-GB" smtClean="0"/>
-              <a:t>31/05/2026</a:t>
+              <a:t>03/07/2026</a:t>
             </a:fld>
             <a:endParaRPr lang="en-GB"/>
           </a:p>
@@ -2535,7 +2536,7 @@
           <a:p>
             <a:fld id="{8727B1B5-114F-462F-9F43-A96471EB3E77}" type="datetimeFigureOut">
               <a:rPr lang="en-GB" smtClean="0"/>
-              <a:t>31/05/2026</a:t>
+              <a:t>03/07/2026</a:t>
             </a:fld>
             <a:endParaRPr lang="en-GB"/>
           </a:p>
@@ -2848,7 +2849,7 @@
           <a:p>
             <a:fld id="{8727B1B5-114F-462F-9F43-A96471EB3E77}" type="datetimeFigureOut">
               <a:rPr lang="en-GB" smtClean="0"/>
-              <a:t>31/05/2026</a:t>
+              <a:t>03/07/2026</a:t>
             </a:fld>
             <a:endParaRPr lang="en-GB"/>
           </a:p>
@@ -3137,7 +3138,7 @@
           <a:p>
             <a:fld id="{8727B1B5-114F-462F-9F43-A96471EB3E77}" type="datetimeFigureOut">
               <a:rPr lang="en-GB" smtClean="0"/>
-              <a:t>31/05/2026</a:t>
+              <a:t>03/07/2026</a:t>
             </a:fld>
             <a:endParaRPr lang="en-GB"/>
           </a:p>
@@ -3380,7 +3381,7 @@
           <a:p>
             <a:fld id="{8727B1B5-114F-462F-9F43-A96471EB3E77}" type="datetimeFigureOut">
               <a:rPr lang="en-GB" smtClean="0"/>
-              <a:t>31/05/2026</a:t>
+              <a:t>03/07/2026</a:t>
             </a:fld>
             <a:endParaRPr lang="en-GB"/>
           </a:p>
@@ -3799,146 +3800,179 @@
       </p:grpSpPr>
       <p:sp>
         <p:nvSpPr>
-          <p:cNvPr id="2" name="Title 1">
-            <a:extLst>
-              <a:ext uri="{FF2B5EF4-FFF2-40B4-BE49-F238E27FC236}">
-                <a16:creationId xmlns:a16="http://schemas.microsoft.com/office/drawing/2014/main" id="{A4440CD0-CA02-870A-881E-AD5144EEA67A}"/>
-              </a:ext>
-            </a:extLst>
-          </p:cNvPr>
-          <p:cNvSpPr>
-            <a:spLocks noGrp="1"/>
-          </p:cNvSpPr>
-          <p:nvPr>
-            <p:ph type="ctrTitle"/>
-          </p:nvPr>
+          <p:cNvPr id="5" name="TextBox 4">
+            <a:extLst>
+              <a:ext uri="{FF2B5EF4-FFF2-40B4-BE49-F238E27FC236}">
+                <a16:creationId xmlns:a16="http://schemas.microsoft.com/office/drawing/2014/main" id="{00AF4E55-95E3-77DF-B8A5-BB8837685860}"/>
+              </a:ext>
+            </a:extLst>
+          </p:cNvPr>
+          <p:cNvSpPr txBox="1"/>
+          <p:nvPr/>
         </p:nvSpPr>
         <p:spPr>
           <a:xfrm>
-            <a:off x="1386348" y="558467"/>
-            <a:ext cx="9144000" cy="1217714"/>
+            <a:off x="0" y="547324"/>
+            <a:ext cx="12191999" cy="892552"/>
           </a:xfrm>
+          <a:prstGeom prst="rect">
+            <a:avLst/>
+          </a:prstGeom>
+          <a:noFill/>
         </p:spPr>
         <p:txBody>
-          <a:bodyPr>
-            <a:normAutofit/>
+          <a:bodyPr wrap="square">
+            <a:spAutoFit/>
           </a:bodyPr>
           <a:lstStyle/>
           <a:p>
-            <a:pPr algn="l"/>
-            <a:r>
-              <a:rPr lang="en-GB" sz="4000" b="1" dirty="0"/>
-              <a:t>Healthcare Analytics Pipeline Project</a:t>
-            </a:r>
-            <a:br>
-              <a:rPr lang="en-GB" sz="4000" b="1" dirty="0"/>
-            </a:br>
-            <a:r>
-              <a:rPr lang="en-GB" sz="4000" b="1" dirty="0"/>
-              <a:t>for Medicare Hospital</a:t>
-            </a:r>
-          </a:p>
-        </p:txBody>
-      </p:sp>
-      <p:sp>
-        <p:nvSpPr>
-          <p:cNvPr id="3" name="Subtitle 2">
-            <a:extLst>
-              <a:ext uri="{FF2B5EF4-FFF2-40B4-BE49-F238E27FC236}">
-                <a16:creationId xmlns:a16="http://schemas.microsoft.com/office/drawing/2014/main" id="{FD549426-1D11-FAB7-3571-B135365C8062}"/>
-              </a:ext>
-            </a:extLst>
-          </p:cNvPr>
-          <p:cNvSpPr>
-            <a:spLocks noGrp="1"/>
-          </p:cNvSpPr>
-          <p:nvPr>
-            <p:ph type="subTitle" idx="1"/>
-          </p:nvPr>
+            <a:pPr algn="ctr"/>
+            <a:r>
+              <a:rPr lang="en-GB" sz="2800" b="1" dirty="0">
+                <a:latin typeface="Aptos" panose="020B0004020202020204" pitchFamily="34" charset="0"/>
+              </a:rPr>
+              <a:t>Healthcare Analytics Pipeline for MediCare Hospital</a:t>
+            </a:r>
+          </a:p>
+          <a:p>
+            <a:pPr algn="ctr"/>
+            <a:r>
+              <a:rPr lang="en-GB" sz="2400" dirty="0"/>
+              <a:t>An End-to-End Scalable Data Engineering &amp; Analytics Platform</a:t>
+            </a:r>
+          </a:p>
+        </p:txBody>
+      </p:sp>
+      <p:sp>
+        <p:nvSpPr>
+          <p:cNvPr id="7" name="TextBox 6">
+            <a:extLst>
+              <a:ext uri="{FF2B5EF4-FFF2-40B4-BE49-F238E27FC236}">
+                <a16:creationId xmlns:a16="http://schemas.microsoft.com/office/drawing/2014/main" id="{17658355-7FE7-E36D-36A8-BF180493B854}"/>
+              </a:ext>
+            </a:extLst>
+          </p:cNvPr>
+          <p:cNvSpPr txBox="1"/>
+          <p:nvPr/>
         </p:nvSpPr>
         <p:spPr>
           <a:xfrm>
-            <a:off x="1386348" y="2310580"/>
-            <a:ext cx="9144000" cy="3880798"/>
+            <a:off x="599768" y="1905286"/>
+            <a:ext cx="6096000" cy="4647426"/>
           </a:xfrm>
+          <a:prstGeom prst="rect">
+            <a:avLst/>
+          </a:prstGeom>
+          <a:noFill/>
         </p:spPr>
         <p:txBody>
-          <a:bodyPr/>
+          <a:bodyPr wrap="square">
+            <a:spAutoFit/>
+          </a:bodyPr>
           <a:lstStyle/>
           <a:p>
-            <a:pPr algn="l"/>
             <a:r>
               <a:rPr lang="en-GB" sz="2000" b="1" dirty="0"/>
               <a:t>Capstone Project</a:t>
             </a:r>
           </a:p>
           <a:p>
-            <a:pPr algn="l"/>
-            <a:endParaRPr lang="en-GB" sz="2000" b="1" dirty="0"/>
-          </a:p>
-          <a:p>
-            <a:pPr algn="l"/>
-            <a:r>
-              <a:rPr lang="en-GB" dirty="0"/>
-              <a:t>Post Graduate Diploma in Data Engineering (PGDDE)</a:t>
-            </a:r>
-            <a:br>
-              <a:rPr lang="en-GB" dirty="0"/>
-            </a:br>
-            <a:r>
-              <a:rPr lang="en-GB" dirty="0"/>
-              <a:t>IIT Jodhpur</a:t>
-            </a:r>
-          </a:p>
-          <a:p>
-            <a:pPr algn="l"/>
-            <a:endParaRPr lang="en-GB" dirty="0"/>
-          </a:p>
-          <a:p>
-            <a:pPr algn="l"/>
+            <a:r>
+              <a:rPr lang="en-GB" sz="2000" b="1" dirty="0"/>
+              <a:t>Group Number: 3</a:t>
+            </a:r>
+          </a:p>
+          <a:p>
+            <a:endParaRPr lang="en-GB" sz="2000" dirty="0"/>
+          </a:p>
+          <a:p>
             <a:r>
               <a:rPr lang="en-GB" sz="2000" b="1" dirty="0"/>
               <a:t>Submitted By</a:t>
             </a:r>
           </a:p>
           <a:p>
-            <a:pPr algn="l"/>
-            <a:r>
-              <a:rPr lang="en-GB" sz="1800" dirty="0"/>
-              <a:t>Arpit Sharma (G25AI1012)</a:t>
-            </a:r>
-            <a:br>
-              <a:rPr lang="en-GB" sz="1800" dirty="0"/>
-            </a:br>
-            <a:r>
-              <a:rPr lang="en-GB" sz="1800" dirty="0"/>
-              <a:t>Ankita Dwivedi (G25AI1011)</a:t>
-            </a:r>
-            <a:br>
-              <a:rPr lang="en-GB" sz="1800" dirty="0"/>
-            </a:br>
-            <a:r>
-              <a:rPr lang="en-GB" sz="1800" dirty="0"/>
-              <a:t>Astosh Ranjan (G25AI1013)</a:t>
-            </a:r>
-            <a:br>
-              <a:rPr lang="en-GB" sz="1800" dirty="0"/>
-            </a:br>
-            <a:r>
-              <a:rPr lang="en-GB" sz="1800" dirty="0"/>
-              <a:t>Bharat Sharma (G25AI1014)</a:t>
-            </a:r>
-            <a:br>
-              <a:rPr lang="en-GB" sz="1800" dirty="0"/>
-            </a:br>
-            <a:r>
-              <a:rPr lang="en-GB" sz="1800" dirty="0"/>
-              <a:t>Damini Khatri (G25AI1015)</a:t>
-            </a:r>
-          </a:p>
-          <a:p>
-            <a:pPr algn="l"/>
             <a:endParaRPr lang="en-GB" dirty="0"/>
+          </a:p>
+          <a:p>
+            <a:r>
+              <a:rPr lang="en-GB" b="1" dirty="0"/>
+              <a:t>     Name                            Roll Number</a:t>
+            </a:r>
+          </a:p>
+          <a:p>
+            <a:pPr marL="285750" indent="-285750">
+              <a:buFont typeface="Wingdings" panose="05000000000000000000" pitchFamily="2" charset="2"/>
+              <a:buChar char="Ø"/>
+            </a:pPr>
+            <a:r>
+              <a:rPr lang="en-GB" dirty="0"/>
+              <a:t>Ankita Dwivedi            G25AI1011</a:t>
+            </a:r>
+          </a:p>
+          <a:p>
+            <a:pPr marL="285750" indent="-285750">
+              <a:buFont typeface="Wingdings" panose="05000000000000000000" pitchFamily="2" charset="2"/>
+              <a:buChar char="Ø"/>
+            </a:pPr>
+            <a:r>
+              <a:rPr lang="en-GB" dirty="0"/>
+              <a:t>Arpit Sharma               G25AI1012</a:t>
+            </a:r>
+          </a:p>
+          <a:p>
+            <a:pPr marL="285750" indent="-285750">
+              <a:buFont typeface="Wingdings" panose="05000000000000000000" pitchFamily="2" charset="2"/>
+              <a:buChar char="Ø"/>
+            </a:pPr>
+            <a:r>
+              <a:rPr lang="en-GB" dirty="0"/>
+              <a:t>Astosh Ranjan             G25AI1013</a:t>
+            </a:r>
+          </a:p>
+          <a:p>
+            <a:pPr marL="285750" indent="-285750">
+              <a:buFont typeface="Wingdings" panose="05000000000000000000" pitchFamily="2" charset="2"/>
+              <a:buChar char="Ø"/>
+            </a:pPr>
+            <a:r>
+              <a:rPr lang="en-GB" dirty="0"/>
+              <a:t>Bharat Sharma            G25AI1014</a:t>
+            </a:r>
+          </a:p>
+          <a:p>
+            <a:pPr marL="285750" indent="-285750">
+              <a:buFont typeface="Wingdings" panose="05000000000000000000" pitchFamily="2" charset="2"/>
+              <a:buChar char="Ø"/>
+            </a:pPr>
+            <a:r>
+              <a:rPr lang="en-GB" dirty="0"/>
+              <a:t>Damini Khatri              G25AI1015</a:t>
+            </a:r>
+          </a:p>
+          <a:p>
+            <a:endParaRPr lang="en-GB" dirty="0"/>
+          </a:p>
+          <a:p>
+            <a:endParaRPr lang="en-GB" dirty="0"/>
+          </a:p>
+          <a:p>
+            <a:r>
+              <a:rPr lang="en-GB" b="1" dirty="0"/>
+              <a:t>Post Graduate Diploma in Data Engineering (PGDDE)</a:t>
+            </a:r>
+          </a:p>
+          <a:p>
+            <a:r>
+              <a:rPr lang="en-GB" b="1" dirty="0"/>
+              <a:t>Indian Institute of Technology Jodhpur</a:t>
+            </a:r>
+          </a:p>
+          <a:p>
+            <a:r>
+              <a:rPr lang="en-GB" b="1" dirty="0"/>
+              <a:t>July 2026</a:t>
+            </a:r>
           </a:p>
         </p:txBody>
       </p:sp>
@@ -4751,10 +4785,10 @@
       </p:grpSpPr>
       <p:sp>
         <p:nvSpPr>
-          <p:cNvPr id="7" name="TextBox 6">
-            <a:extLst>
-              <a:ext uri="{FF2B5EF4-FFF2-40B4-BE49-F238E27FC236}">
-                <a16:creationId xmlns:a16="http://schemas.microsoft.com/office/drawing/2014/main" id="{02E96928-E3AF-658A-B9B5-615FA0379884}"/>
+          <p:cNvPr id="3" name="TextBox 2">
+            <a:extLst>
+              <a:ext uri="{FF2B5EF4-FFF2-40B4-BE49-F238E27FC236}">
+                <a16:creationId xmlns:a16="http://schemas.microsoft.com/office/drawing/2014/main" id="{A3876A29-32A1-E3DB-FCB8-13D27EFFB57D}"/>
               </a:ext>
             </a:extLst>
           </p:cNvPr>
@@ -4763,8 +4797,8 @@
         </p:nvSpPr>
         <p:spPr>
           <a:xfrm>
-            <a:off x="1081549" y="458956"/>
-            <a:ext cx="6096000" cy="6093976"/>
+            <a:off x="1071717" y="566678"/>
+            <a:ext cx="9635612" cy="4001095"/>
           </a:xfrm>
           <a:prstGeom prst="rect">
             <a:avLst/>
@@ -4777,113 +4811,445 @@
           </a:bodyPr>
           <a:lstStyle/>
           <a:p>
-            <a:r>
-              <a:rPr lang="en-GB" sz="3200" b="1" dirty="0"/>
-              <a:t>Conclusion &amp; Future Scope</a:t>
-            </a:r>
-          </a:p>
-          <a:p>
+            <a:pPr>
+              <a:buNone/>
+            </a:pPr>
+            <a:r>
+              <a:rPr lang="en-GB" sz="2800" b="1" dirty="0"/>
+              <a:t>Key Results Achieved</a:t>
+            </a:r>
+          </a:p>
+          <a:p>
+            <a:pPr>
+              <a:buNone/>
+            </a:pPr>
+            <a:endParaRPr lang="en-GB" sz="2800" b="1" dirty="0"/>
+          </a:p>
+          <a:p>
+            <a:pPr marL="285750" indent="-285750" algn="just">
+              <a:buFont typeface="Arial" panose="020B0604020202020204" pitchFamily="34" charset="0"/>
+              <a:buChar char="•"/>
+            </a:pPr>
+            <a:r>
+              <a:rPr lang="en-GB" dirty="0"/>
+              <a:t> Processed </a:t>
+            </a:r>
+            <a:r>
+              <a:rPr lang="en-GB" b="1" dirty="0"/>
+              <a:t>5000+ healthcare records</a:t>
+            </a:r>
+            <a:r>
+              <a:rPr lang="en-GB" dirty="0"/>
+              <a:t> through an end-to-end analytics pipeline.</a:t>
+            </a:r>
+          </a:p>
+          <a:p>
+            <a:pPr marL="285750" indent="-285750" algn="just">
+              <a:buFont typeface="Arial" panose="020B0604020202020204" pitchFamily="34" charset="0"/>
+              <a:buChar char="•"/>
+            </a:pPr>
+            <a:r>
+              <a:rPr lang="en-GB" dirty="0"/>
+              <a:t> Built a healthcare data engineering and analytics platform using AWS S3, PostgreSQL, </a:t>
+            </a:r>
+          </a:p>
+          <a:p>
+            <a:pPr algn="just"/>
+            <a:r>
+              <a:rPr lang="en-GB" dirty="0"/>
+              <a:t>       Airflow, PySpark, and Databricks.</a:t>
+            </a:r>
+          </a:p>
+          <a:p>
+            <a:pPr marL="285750" indent="-285750" algn="just">
+              <a:buFont typeface="Arial" panose="020B0604020202020204" pitchFamily="34" charset="0"/>
+              <a:buChar char="•"/>
+            </a:pPr>
+            <a:r>
+              <a:rPr lang="en-GB" dirty="0"/>
+              <a:t> Implemented </a:t>
+            </a:r>
+            <a:r>
+              <a:rPr lang="en-GB" b="1" dirty="0"/>
+              <a:t>real-time healthcare data streaming</a:t>
+            </a:r>
+            <a:r>
+              <a:rPr lang="en-GB" dirty="0"/>
+              <a:t> using Apache Kafka.</a:t>
+            </a:r>
+          </a:p>
+          <a:p>
+            <a:pPr marL="285750" indent="-285750" algn="just">
+              <a:buFont typeface="Arial" panose="020B0604020202020204" pitchFamily="34" charset="0"/>
+              <a:buChar char="•"/>
+            </a:pPr>
+            <a:r>
+              <a:rPr lang="en-GB" dirty="0"/>
+              <a:t> Developed an </a:t>
+            </a:r>
+            <a:r>
+              <a:rPr lang="en-GB" b="1" dirty="0"/>
+              <a:t>interactive Streamlit dashboard</a:t>
+            </a:r>
+            <a:r>
+              <a:rPr lang="en-GB" dirty="0"/>
+              <a:t> with dynamic filtering and KPI visualization.</a:t>
+            </a:r>
+          </a:p>
+          <a:p>
+            <a:pPr marL="285750" indent="-285750" algn="just">
+              <a:buFont typeface="Arial" panose="020B0604020202020204" pitchFamily="34" charset="0"/>
+              <a:buChar char="•"/>
+            </a:pPr>
+            <a:r>
+              <a:rPr lang="en-GB" dirty="0"/>
+              <a:t> Generated </a:t>
+            </a:r>
+            <a:r>
+              <a:rPr lang="en-GB" b="1" dirty="0"/>
+              <a:t>disease distribution, treatment cost, admission trends, and patient analytics</a:t>
+            </a:r>
+            <a:r>
+              <a:rPr lang="en-GB" dirty="0"/>
+              <a:t>.</a:t>
+            </a:r>
+          </a:p>
+          <a:p>
+            <a:pPr marL="285750" indent="-285750" algn="just">
+              <a:buFont typeface="Arial" panose="020B0604020202020204" pitchFamily="34" charset="0"/>
+              <a:buChar char="•"/>
+            </a:pPr>
+            <a:r>
+              <a:rPr lang="en-GB" dirty="0"/>
+              <a:t> Integrated </a:t>
+            </a:r>
+            <a:r>
+              <a:rPr lang="en-GB" b="1" dirty="0"/>
+              <a:t>Machine Learning (Random Forest)</a:t>
+            </a:r>
+            <a:r>
+              <a:rPr lang="en-GB" dirty="0"/>
+              <a:t> for predictive healthcare analytics.</a:t>
+            </a:r>
+          </a:p>
+          <a:p>
+            <a:pPr marL="285750" indent="-285750" algn="just">
+              <a:buFont typeface="Arial" panose="020B0604020202020204" pitchFamily="34" charset="0"/>
+              <a:buChar char="•"/>
+            </a:pPr>
+            <a:r>
+              <a:rPr lang="en-GB" dirty="0"/>
+              <a:t> Implemented </a:t>
+            </a:r>
+            <a:r>
+              <a:rPr lang="en-GB" b="1" dirty="0"/>
+              <a:t>GitHub Actions CI/CD automation</a:t>
+            </a:r>
+            <a:r>
+              <a:rPr lang="en-GB" dirty="0"/>
+              <a:t> for workflow validation and </a:t>
+            </a:r>
+          </a:p>
+          <a:p>
+            <a:pPr algn="just"/>
+            <a:r>
+              <a:rPr lang="en-GB" dirty="0"/>
+              <a:t>       deployment readiness.</a:t>
+            </a:r>
+          </a:p>
+          <a:p>
+            <a:pPr algn="just"/>
             <a:endParaRPr lang="en-GB" dirty="0"/>
           </a:p>
           <a:p>
-            <a:r>
-              <a:rPr lang="en-GB" sz="2000" dirty="0"/>
-              <a:t>• Built a complete Healthcare Analytics Pipeline.</a:t>
-            </a:r>
-          </a:p>
-          <a:p>
-            <a:r>
-              <a:rPr lang="en-GB" sz="2000" dirty="0"/>
-              <a:t>• </a:t>
-            </a:r>
-            <a:r>
-              <a:rPr lang="en-US" sz="2000" dirty="0"/>
-              <a:t>Integrated AWS S3, Apache Kafka, Databricks, </a:t>
-            </a:r>
-          </a:p>
-          <a:p>
-            <a:r>
-              <a:rPr lang="en-US" sz="2000" dirty="0"/>
-              <a:t>   Airflow, PySpark and PostgreSQL.</a:t>
-            </a:r>
-            <a:endParaRPr lang="en-GB" sz="2000" dirty="0"/>
-          </a:p>
-          <a:p>
-            <a:r>
-              <a:rPr lang="en-GB" sz="2000" dirty="0"/>
-              <a:t>• Designed a Star Schema Data Warehouse.</a:t>
-            </a:r>
-          </a:p>
-          <a:p>
-            <a:r>
-              <a:rPr lang="en-GB" sz="2000" dirty="0"/>
-              <a:t>• Developed an Interactive Streamlit Dashboard.</a:t>
-            </a:r>
-          </a:p>
-          <a:p>
-            <a:r>
-              <a:rPr lang="en-GB" sz="2000" dirty="0"/>
-              <a:t>• Implemented Machine Learning based Analytics.</a:t>
-            </a:r>
-          </a:p>
-          <a:p>
-            <a:r>
-              <a:rPr lang="en-US" sz="2000" dirty="0"/>
-              <a:t>• Implemented GitHub Actions based CI/CD workflow.</a:t>
-            </a:r>
-            <a:endParaRPr lang="en-GB" sz="2000" dirty="0"/>
-          </a:p>
-          <a:p>
+            <a:pPr>
+              <a:buNone/>
+            </a:pPr>
             <a:endParaRPr lang="en-GB" dirty="0"/>
           </a:p>
-          <a:p>
-            <a:r>
-              <a:rPr lang="en-GB" sz="3200" b="1" dirty="0"/>
-              <a:t>Future Scope</a:t>
-            </a:r>
-          </a:p>
-          <a:p>
-            <a:endParaRPr lang="en-GB" dirty="0"/>
-          </a:p>
-          <a:p>
-            <a:r>
-              <a:rPr lang="en-US" sz="2000" dirty="0"/>
-              <a:t>• Snowflake Data Warehouse integration</a:t>
-            </a:r>
-          </a:p>
-          <a:p>
-            <a:r>
-              <a:rPr lang="en-US" sz="2000" dirty="0"/>
-              <a:t>• Kubernetes-based container orchestration</a:t>
-            </a:r>
-          </a:p>
-          <a:p>
-            <a:r>
-              <a:rPr lang="en-US" sz="2000" dirty="0"/>
-              <a:t>• Advanced predictive analytics</a:t>
-            </a:r>
-          </a:p>
-          <a:p>
-            <a:r>
-              <a:rPr lang="en-US" sz="2000" dirty="0"/>
-              <a:t>• Integration with hospital information systems</a:t>
-            </a:r>
-          </a:p>
-          <a:p>
-            <a:endParaRPr lang="en-GB" sz="2000" dirty="0"/>
-          </a:p>
-          <a:p>
-            <a:r>
-              <a:rPr lang="en-GB" sz="3200" b="1" dirty="0"/>
-              <a:t>Thank You</a:t>
-            </a:r>
-          </a:p>
-        </p:txBody>
-      </p:sp>
+        </p:txBody>
+      </p:sp>
+      <p:pic>
+        <p:nvPicPr>
+          <p:cNvPr id="7" name="Picture 6">
+            <a:extLst>
+              <a:ext uri="{FF2B5EF4-FFF2-40B4-BE49-F238E27FC236}">
+                <a16:creationId xmlns:a16="http://schemas.microsoft.com/office/drawing/2014/main" id="{678D9886-49D7-7936-85ED-21E7D8A2DC09}"/>
+              </a:ext>
+            </a:extLst>
+          </p:cNvPr>
+          <p:cNvPicPr>
+            <a:picLocks noChangeAspect="1"/>
+          </p:cNvPicPr>
+          <p:nvPr/>
+        </p:nvPicPr>
+        <p:blipFill>
+          <a:blip r:embed="rId2">
+            <a:extLst>
+              <a:ext uri="{28A0092B-C50C-407E-A947-70E740481C1C}">
+                <a14:useLocalDpi xmlns:a14="http://schemas.microsoft.com/office/drawing/2010/main" val="0"/>
+              </a:ext>
+            </a:extLst>
+          </a:blip>
+          <a:srcRect/>
+          <a:stretch/>
+        </p:blipFill>
+        <p:spPr>
+          <a:xfrm>
+            <a:off x="845574" y="4365524"/>
+            <a:ext cx="5043949" cy="2158756"/>
+          </a:xfrm>
+          <a:prstGeom prst="rect">
+            <a:avLst/>
+          </a:prstGeom>
+        </p:spPr>
+      </p:pic>
+      <p:pic>
+        <p:nvPicPr>
+          <p:cNvPr id="9" name="Picture 8">
+            <a:extLst>
+              <a:ext uri="{FF2B5EF4-FFF2-40B4-BE49-F238E27FC236}">
+                <a16:creationId xmlns:a16="http://schemas.microsoft.com/office/drawing/2014/main" id="{3C39FDF8-0A37-9338-00E9-D0C94A2932DC}"/>
+              </a:ext>
+            </a:extLst>
+          </p:cNvPr>
+          <p:cNvPicPr>
+            <a:picLocks noChangeAspect="1"/>
+          </p:cNvPicPr>
+          <p:nvPr/>
+        </p:nvPicPr>
+        <p:blipFill>
+          <a:blip r:embed="rId3">
+            <a:extLst>
+              <a:ext uri="{28A0092B-C50C-407E-A947-70E740481C1C}">
+                <a14:useLocalDpi xmlns:a14="http://schemas.microsoft.com/office/drawing/2010/main" val="0"/>
+              </a:ext>
+            </a:extLst>
+          </a:blip>
+          <a:srcRect/>
+          <a:stretch/>
+        </p:blipFill>
+        <p:spPr>
+          <a:xfrm>
+            <a:off x="6449961" y="4365524"/>
+            <a:ext cx="5043949" cy="2158756"/>
+          </a:xfrm>
+          <a:prstGeom prst="rect">
+            <a:avLst/>
+          </a:prstGeom>
+        </p:spPr>
+      </p:pic>
     </p:spTree>
     <p:extLst>
       <p:ext uri="{BB962C8B-B14F-4D97-AF65-F5344CB8AC3E}">
-        <p14:creationId xmlns:p14="http://schemas.microsoft.com/office/powerpoint/2010/main" val="1636613480"/>
+        <p14:creationId xmlns:p14="http://schemas.microsoft.com/office/powerpoint/2010/main" val="1182394040"/>
+      </p:ext>
+    </p:extLst>
+  </p:cSld>
+  <p:clrMapOvr>
+    <a:masterClrMapping/>
+  </p:clrMapOvr>
+</p:sld>
+</file>
+
+<file path=ppt/slides/slide15.xml><?xml version="1.0" encoding="utf-8"?>
+<p:sld xmlns:a="http://schemas.openxmlformats.org/drawingml/2006/main" xmlns:r="http://schemas.openxmlformats.org/officeDocument/2006/relationships" xmlns:p="http://schemas.openxmlformats.org/presentationml/2006/main">
+  <p:cSld>
+    <p:spTree>
+      <p:nvGrpSpPr>
+        <p:cNvPr id="1" name=""/>
+        <p:cNvGrpSpPr/>
+        <p:nvPr/>
+      </p:nvGrpSpPr>
+      <p:grpSpPr>
+        <a:xfrm>
+          <a:off x="0" y="0"/>
+          <a:ext cx="0" cy="0"/>
+          <a:chOff x="0" y="0"/>
+          <a:chExt cx="0" cy="0"/>
+        </a:xfrm>
+      </p:grpSpPr>
+      <p:sp>
+        <p:nvSpPr>
+          <p:cNvPr id="3" name="TextBox 2">
+            <a:extLst>
+              <a:ext uri="{FF2B5EF4-FFF2-40B4-BE49-F238E27FC236}">
+                <a16:creationId xmlns:a16="http://schemas.microsoft.com/office/drawing/2014/main" id="{43A1AC31-2B9D-1AD1-06C6-B5C0D4B32E90}"/>
+              </a:ext>
+            </a:extLst>
+          </p:cNvPr>
+          <p:cNvSpPr txBox="1"/>
+          <p:nvPr/>
+        </p:nvSpPr>
+        <p:spPr>
+          <a:xfrm>
+            <a:off x="1081548" y="458956"/>
+            <a:ext cx="10363199" cy="6217087"/>
+          </a:xfrm>
+          <a:prstGeom prst="rect">
+            <a:avLst/>
+          </a:prstGeom>
+          <a:noFill/>
+        </p:spPr>
+        <p:txBody>
+          <a:bodyPr wrap="square">
+            <a:spAutoFit/>
+          </a:bodyPr>
+          <a:lstStyle/>
+          <a:p>
+            <a:r>
+              <a:rPr lang="en-GB" sz="3200" b="1" dirty="0"/>
+              <a:t>Conclusion</a:t>
+            </a:r>
+          </a:p>
+          <a:p>
+            <a:endParaRPr lang="en-GB" dirty="0"/>
+          </a:p>
+          <a:p>
+            <a:pPr marL="342900" indent="-342900">
+              <a:buFont typeface="Arial" panose="020B0604020202020204" pitchFamily="34" charset="0"/>
+              <a:buChar char="•"/>
+            </a:pPr>
+            <a:r>
+              <a:rPr lang="en-GB" sz="2000" dirty="0"/>
+              <a:t>Built a complete Healthcare Analytics Pipeline.</a:t>
+            </a:r>
+          </a:p>
+          <a:p>
+            <a:pPr marL="342900" indent="-342900">
+              <a:buFont typeface="Arial" panose="020B0604020202020204" pitchFamily="34" charset="0"/>
+              <a:buChar char="•"/>
+            </a:pPr>
+            <a:r>
+              <a:rPr lang="en-US" sz="2000" dirty="0"/>
+              <a:t>Integrated AWS S3, Apache Kafka, Databricks, Airflow, PySpark and PostgreSQL.</a:t>
+            </a:r>
+            <a:endParaRPr lang="en-GB" sz="2000" dirty="0"/>
+          </a:p>
+          <a:p>
+            <a:pPr marL="342900" indent="-342900">
+              <a:buFont typeface="Arial" panose="020B0604020202020204" pitchFamily="34" charset="0"/>
+              <a:buChar char="•"/>
+            </a:pPr>
+            <a:r>
+              <a:rPr lang="en-GB" sz="2000" dirty="0"/>
+              <a:t>Designed a Star Schema Data Warehouse.</a:t>
+            </a:r>
+          </a:p>
+          <a:p>
+            <a:pPr marL="342900" indent="-342900">
+              <a:buFont typeface="Arial" panose="020B0604020202020204" pitchFamily="34" charset="0"/>
+              <a:buChar char="•"/>
+            </a:pPr>
+            <a:r>
+              <a:rPr lang="en-GB" sz="2000" dirty="0"/>
+              <a:t>Developed an Interactive Streamlit Dashboard.</a:t>
+            </a:r>
+          </a:p>
+          <a:p>
+            <a:pPr marL="342900" indent="-342900">
+              <a:buFont typeface="Arial" panose="020B0604020202020204" pitchFamily="34" charset="0"/>
+              <a:buChar char="•"/>
+            </a:pPr>
+            <a:r>
+              <a:rPr lang="en-GB" sz="2000" dirty="0"/>
+              <a:t>Implemented Machine Learning based Analytics.</a:t>
+            </a:r>
+          </a:p>
+          <a:p>
+            <a:pPr marL="342900" indent="-342900">
+              <a:buFont typeface="Arial" panose="020B0604020202020204" pitchFamily="34" charset="0"/>
+              <a:buChar char="•"/>
+            </a:pPr>
+            <a:r>
+              <a:rPr lang="en-US" sz="2000" dirty="0"/>
+              <a:t>Implemented GitHub Actions based CI/CD workflow.</a:t>
+            </a:r>
+          </a:p>
+          <a:p>
+            <a:endParaRPr lang="en-US" sz="2000" dirty="0"/>
+          </a:p>
+          <a:p>
+            <a:r>
+              <a:rPr lang="en-GB" sz="3200" b="1" dirty="0"/>
+              <a:t>Future Scope</a:t>
+            </a:r>
+          </a:p>
+          <a:p>
+            <a:endParaRPr lang="en-US" sz="2000" dirty="0"/>
+          </a:p>
+          <a:p>
+            <a:pPr marL="342900" indent="-342900">
+              <a:buFont typeface="Arial" panose="020B0604020202020204" pitchFamily="34" charset="0"/>
+              <a:buChar char="•"/>
+            </a:pPr>
+            <a:r>
+              <a:rPr lang="en-US" sz="2000" dirty="0"/>
+              <a:t>Snowflake Data Warehouse Integration.</a:t>
+            </a:r>
+          </a:p>
+          <a:p>
+            <a:pPr marL="342900" indent="-342900">
+              <a:buFont typeface="Arial" panose="020B0604020202020204" pitchFamily="34" charset="0"/>
+              <a:buChar char="•"/>
+            </a:pPr>
+            <a:r>
+              <a:rPr lang="en-US" sz="2000" dirty="0"/>
+              <a:t>Kubernetes-based Container Orchestration.</a:t>
+            </a:r>
+          </a:p>
+          <a:p>
+            <a:pPr marL="342900" indent="-342900">
+              <a:buFont typeface="Arial" panose="020B0604020202020204" pitchFamily="34" charset="0"/>
+              <a:buChar char="•"/>
+            </a:pPr>
+            <a:r>
+              <a:rPr lang="en-US" sz="2000" dirty="0"/>
+              <a:t>Production-grade Apache Kafka Streaming.</a:t>
+            </a:r>
+          </a:p>
+          <a:p>
+            <a:pPr marL="342900" indent="-342900">
+              <a:buFont typeface="Arial" panose="020B0604020202020204" pitchFamily="34" charset="0"/>
+              <a:buChar char="•"/>
+            </a:pPr>
+            <a:r>
+              <a:rPr lang="en-US" sz="2000" dirty="0"/>
+              <a:t>Integration with Hospital Information Systems.</a:t>
+            </a:r>
+          </a:p>
+          <a:p>
+            <a:pPr marL="342900" indent="-342900">
+              <a:buFont typeface="Arial" panose="020B0604020202020204" pitchFamily="34" charset="0"/>
+              <a:buChar char="•"/>
+            </a:pPr>
+            <a:r>
+              <a:rPr lang="en-US" sz="2000" dirty="0"/>
+              <a:t>Advanced Predictive Analytics &amp; Real-time Alerts.</a:t>
+            </a:r>
+            <a:endParaRPr lang="en-GB" sz="2000" dirty="0"/>
+          </a:p>
+          <a:p>
+            <a:pPr algn="ctr"/>
+            <a:r>
+              <a:rPr lang="en-GB" sz="2800" b="1" dirty="0"/>
+              <a:t>                                                    </a:t>
+            </a:r>
+          </a:p>
+          <a:p>
+            <a:pPr algn="ctr"/>
+            <a:r>
+              <a:rPr lang="en-GB" sz="2800" b="1" dirty="0"/>
+              <a:t>Thank You!                                                    </a:t>
+            </a:r>
+            <a:endParaRPr lang="en-GB" sz="2000" dirty="0"/>
+          </a:p>
+        </p:txBody>
+      </p:sp>
+    </p:spTree>
+    <p:extLst>
+      <p:ext uri="{BB962C8B-B14F-4D97-AF65-F5344CB8AC3E}">
+        <p14:creationId xmlns:p14="http://schemas.microsoft.com/office/powerpoint/2010/main" val="2838295901"/>
       </p:ext>
     </p:extLst>
   </p:cSld>
@@ -4924,8 +5290,8 @@
         </p:nvSpPr>
         <p:spPr>
           <a:xfrm>
-            <a:off x="855407" y="792350"/>
-            <a:ext cx="10245213" cy="5078313"/>
+            <a:off x="973393" y="26641"/>
+            <a:ext cx="10245213" cy="7171194"/>
           </a:xfrm>
           <a:prstGeom prst="rect">
             <a:avLst/>
@@ -4944,7 +5310,7 @@
             </a:r>
           </a:p>
           <a:p>
-            <a:endParaRPr lang="en-GB" sz="2400" dirty="0"/>
+            <a:endParaRPr lang="en-GB" sz="1200" dirty="0"/>
           </a:p>
           <a:p>
             <a:r>
@@ -4977,7 +5343,7 @@
             </a:r>
           </a:p>
           <a:p>
-            <a:endParaRPr lang="en-GB" sz="2400" dirty="0"/>
+            <a:endParaRPr lang="en-GB" sz="1400" dirty="0"/>
           </a:p>
           <a:p>
             <a:r>
@@ -4986,7 +5352,7 @@
             </a:r>
           </a:p>
           <a:p>
-            <a:endParaRPr lang="en-GB" sz="3200" dirty="0"/>
+            <a:endParaRPr lang="en-GB" sz="1200" dirty="0"/>
           </a:p>
           <a:p>
             <a:r>
@@ -5012,8 +5378,72 @@
             </a:br>
             <a:r>
               <a:rPr lang="en-GB" sz="2000" dirty="0"/>
-              <a:t>• Enable scalable and cloud-based healthcare analytics.</a:t>
-            </a:r>
+              <a:t>• Enable scalable healthcare analytics by leveraging cloud services.</a:t>
+            </a:r>
+          </a:p>
+          <a:p>
+            <a:endParaRPr lang="en-GB" sz="1400" dirty="0"/>
+          </a:p>
+          <a:p>
+            <a:r>
+              <a:rPr lang="en-US" sz="3200" b="1" dirty="0"/>
+              <a:t>Project Resources</a:t>
+            </a:r>
+          </a:p>
+          <a:p>
+            <a:endParaRPr lang="en-US" sz="1200" dirty="0"/>
+          </a:p>
+          <a:p>
+            <a:r>
+              <a:rPr lang="en-US" sz="2000" dirty="0"/>
+              <a:t>• </a:t>
+            </a:r>
+            <a:r>
+              <a:rPr lang="en-US" sz="2000" b="1" dirty="0"/>
+              <a:t>GitHub Repository:</a:t>
+            </a:r>
+          </a:p>
+          <a:p>
+            <a:r>
+              <a:rPr lang="en-US" sz="2000" dirty="0"/>
+              <a:t>  </a:t>
+            </a:r>
+            <a:r>
+              <a:rPr lang="en-US" sz="2000" dirty="0">
+                <a:hlinkClick r:id="rId2"/>
+              </a:rPr>
+              <a:t>https://github.com/arpit-systems/healthcare-analytics-pipeline</a:t>
+            </a:r>
+            <a:endParaRPr lang="en-US" sz="2000" dirty="0"/>
+          </a:p>
+          <a:p>
+            <a:endParaRPr lang="en-US" sz="2000" dirty="0"/>
+          </a:p>
+          <a:p>
+            <a:r>
+              <a:rPr lang="en-US" sz="2000" dirty="0"/>
+              <a:t>• </a:t>
+            </a:r>
+            <a:r>
+              <a:rPr lang="en-US" sz="2000" b="1" dirty="0"/>
+              <a:t>Final Project Report:</a:t>
+            </a:r>
+          </a:p>
+          <a:p>
+            <a:r>
+              <a:rPr lang="en-GB" sz="2000" dirty="0"/>
+              <a:t> </a:t>
+            </a:r>
+            <a:r>
+              <a:rPr lang="en-GB" sz="2000" dirty="0">
+                <a:hlinkClick r:id="rId3"/>
+              </a:rPr>
+              <a:t>https://drive.google.com/file/d/178q8gNesaShG-yQghYCeDS8-bwI6Nsow/view?usp=sharing</a:t>
+            </a:r>
+            <a:endParaRPr lang="en-GB" sz="2000" dirty="0"/>
+          </a:p>
+          <a:p>
+            <a:endParaRPr lang="en-GB" sz="2000" dirty="0"/>
           </a:p>
         </p:txBody>
       </p:sp>
@@ -5086,7 +5516,11 @@
           <a:p>
             <a:r>
               <a:rPr lang="en-US" sz="2000" dirty="0"/>
-              <a:t>• Cloud-based end-to-end analytics pipeline</a:t>
+              <a:t>• </a:t>
+            </a:r>
+            <a:r>
+              <a:rPr lang="en-GB" sz="2000" dirty="0"/>
+              <a:t>Integrated Healthcare Data Engineering Architecture</a:t>
             </a:r>
           </a:p>
           <a:p>
@@ -5156,14 +5590,13 @@
               </a:ext>
             </a:extLst>
           </a:blip>
-          <a:stretch>
-            <a:fillRect/>
-          </a:stretch>
+          <a:srcRect/>
+          <a:stretch/>
         </p:blipFill>
         <p:spPr>
           <a:xfrm>
-            <a:off x="380999" y="167148"/>
-            <a:ext cx="5538020" cy="6449962"/>
+            <a:off x="569104" y="167148"/>
+            <a:ext cx="5161809" cy="6449962"/>
           </a:xfrm>
           <a:prstGeom prst="rect">
             <a:avLst/>

</xml_diff>

<commit_message>
Add final capstone presentation slides
Uploaded the final presentation slides for the Healthcare Analytics Pipeline capstone project, including project overview, architecture, implementation, analytics, machine learning, dashboard demonstration, and key results.
</commit_message>
<xml_diff>
--- a/PGDDE_Capstone_Healthcare_Analytics_Pipeline_IITJ.pptx
+++ b/PGDDE_Capstone_Healthcare_Analytics_Pipeline_IITJ.pptx
@@ -5291,7 +5291,7 @@
         <p:spPr>
           <a:xfrm>
             <a:off x="973393" y="26641"/>
-            <a:ext cx="10245213" cy="7171194"/>
+            <a:ext cx="10245213" cy="6863417"/>
           </a:xfrm>
           <a:prstGeom prst="rect">
             <a:avLst/>
@@ -5417,9 +5417,6 @@
             <a:endParaRPr lang="en-US" sz="2000" dirty="0"/>
           </a:p>
           <a:p>
-            <a:endParaRPr lang="en-US" sz="2000" dirty="0"/>
-          </a:p>
-          <a:p>
             <a:r>
               <a:rPr lang="en-US" sz="2000" dirty="0"/>
               <a:t>• </a:t>
@@ -5438,7 +5435,7 @@
               <a:rPr lang="en-GB" sz="2000" dirty="0">
                 <a:hlinkClick r:id="rId3"/>
               </a:rPr>
-              <a:t>https://drive.google.com/file/d/178q8gNesaShG-yQghYCeDS8-bwI6Nsow/view?usp=sharing</a:t>
+              <a:t>https://drive.google.com/file/d/1gJPl8zC-l_vYn_bC0B9SGhOb3Uhrsf_k/view?usp=sharing</a:t>
             </a:r>
             <a:endParaRPr lang="en-GB" sz="2000" dirty="0"/>
           </a:p>
@@ -5835,7 +5832,7 @@
         </p:nvSpPr>
         <p:spPr>
           <a:xfrm>
-            <a:off x="6902246" y="3742526"/>
+            <a:off x="7079226" y="3737693"/>
             <a:ext cx="5034115" cy="2893100"/>
           </a:xfrm>
           <a:prstGeom prst="rect">

</xml_diff>